<commit_message>
Add animation sound to every click reveal in fathah and kasrah decks
Co-Authored-By: Claude Sonnet 5.5 <noreply@anthropic.com>
Claude-Session: https://claude.ai/code/session_01FzFnzdoj1sJJKm8jQJSfJE
</commit_message>
<xml_diff>
--- a/all-letters-kasrah/01-alif.pptx
+++ b/all-letters-kasrah/01-alif.pptx
@@ -3154,6 +3154,25 @@
                                         </p:tgtEl>
                                       </p:cBhvr>
                                     </p:animEffect>
+                                    <p:audio>
+                                      <p:cMediaNode vol="80000">
+                                        <p:cTn id="1001" display="0">
+                                          <p:stCondLst>
+                                            <p:cond delay="0"/>
+                                          </p:stCondLst>
+                                          <p:endCondLst>
+                                            <p:cond evt="onStopAudio" delay="0">
+                                              <p:tgtEl>
+                                                <p:sldTgt/>
+                                              </p:tgtEl>
+                                            </p:cond>
+                                          </p:endCondLst>
+                                        </p:cTn>
+                                        <p:tgtEl>
+                                          <p:sndTgt r:embed="rIdSnd1" name="pop.wav"/>
+                                        </p:tgtEl>
+                                      </p:cMediaNode>
+                                    </p:audio>
                                   </p:childTnLst>
                                 </p:cTn>
                               </p:par>
@@ -3207,6 +3226,25 @@
                                         </p:tgtEl>
                                       </p:cBhvr>
                                     </p:animEffect>
+                                    <p:audio>
+                                      <p:cMediaNode vol="80000">
+                                        <p:cTn id="1002" display="0">
+                                          <p:stCondLst>
+                                            <p:cond delay="0"/>
+                                          </p:stCondLst>
+                                          <p:endCondLst>
+                                            <p:cond evt="onStopAudio" delay="0">
+                                              <p:tgtEl>
+                                                <p:sldTgt/>
+                                              </p:tgtEl>
+                                            </p:cond>
+                                          </p:endCondLst>
+                                        </p:cTn>
+                                        <p:tgtEl>
+                                          <p:sndTgt r:embed="rIdSnd2" name="ding.wav"/>
+                                        </p:tgtEl>
+                                      </p:cMediaNode>
+                                    </p:audio>
                                   </p:childTnLst>
                                 </p:cTn>
                               </p:par>
@@ -4026,6 +4064,25 @@
                                         </p:tgtEl>
                                       </p:cBhvr>
                                     </p:animEffect>
+                                    <p:audio>
+                                      <p:cMediaNode vol="80000">
+                                        <p:cTn id="1001" display="0">
+                                          <p:stCondLst>
+                                            <p:cond delay="0"/>
+                                          </p:stCondLst>
+                                          <p:endCondLst>
+                                            <p:cond evt="onStopAudio" delay="0">
+                                              <p:tgtEl>
+                                                <p:sldTgt/>
+                                              </p:tgtEl>
+                                            </p:cond>
+                                          </p:endCondLst>
+                                        </p:cTn>
+                                        <p:tgtEl>
+                                          <p:sndTgt r:embed="rIdSnd1" name="pop.wav"/>
+                                        </p:tgtEl>
+                                      </p:cMediaNode>
+                                    </p:audio>
                                   </p:childTnLst>
                                 </p:cTn>
                               </p:par>
@@ -4079,6 +4136,25 @@
                                         </p:tgtEl>
                                       </p:cBhvr>
                                     </p:animEffect>
+                                    <p:audio>
+                                      <p:cMediaNode vol="80000">
+                                        <p:cTn id="1002" display="0">
+                                          <p:stCondLst>
+                                            <p:cond delay="0"/>
+                                          </p:stCondLst>
+                                          <p:endCondLst>
+                                            <p:cond evt="onStopAudio" delay="0">
+                                              <p:tgtEl>
+                                                <p:sldTgt/>
+                                              </p:tgtEl>
+                                            </p:cond>
+                                          </p:endCondLst>
+                                        </p:cTn>
+                                        <p:tgtEl>
+                                          <p:sndTgt r:embed="rIdSnd2" name="ding.wav"/>
+                                        </p:tgtEl>
+                                      </p:cMediaNode>
+                                    </p:audio>
                                   </p:childTnLst>
                                 </p:cTn>
                               </p:par>
@@ -4132,6 +4208,25 @@
                                         </p:tgtEl>
                                       </p:cBhvr>
                                     </p:animEffect>
+                                    <p:audio>
+                                      <p:cMediaNode vol="80000">
+                                        <p:cTn id="1003" display="0">
+                                          <p:stCondLst>
+                                            <p:cond delay="0"/>
+                                          </p:stCondLst>
+                                          <p:endCondLst>
+                                            <p:cond evt="onStopAudio" delay="0">
+                                              <p:tgtEl>
+                                                <p:sldTgt/>
+                                              </p:tgtEl>
+                                            </p:cond>
+                                          </p:endCondLst>
+                                        </p:cTn>
+                                        <p:tgtEl>
+                                          <p:sndTgt r:embed="rIdSnd3" name="tick.wav"/>
+                                        </p:tgtEl>
+                                      </p:cMediaNode>
+                                    </p:audio>
                                   </p:childTnLst>
                                 </p:cTn>
                               </p:par>
@@ -4185,6 +4280,25 @@
                                         </p:tgtEl>
                                       </p:cBhvr>
                                     </p:animEffect>
+                                    <p:audio>
+                                      <p:cMediaNode vol="80000">
+                                        <p:cTn id="1004" display="0">
+                                          <p:stCondLst>
+                                            <p:cond delay="0"/>
+                                          </p:stCondLst>
+                                          <p:endCondLst>
+                                            <p:cond evt="onStopAudio" delay="0">
+                                              <p:tgtEl>
+                                                <p:sldTgt/>
+                                              </p:tgtEl>
+                                            </p:cond>
+                                          </p:endCondLst>
+                                        </p:cTn>
+                                        <p:tgtEl>
+                                          <p:sndTgt r:embed="rIdSnd1" name="pop.wav"/>
+                                        </p:tgtEl>
+                                      </p:cMediaNode>
+                                    </p:audio>
                                   </p:childTnLst>
                                 </p:cTn>
                               </p:par>
@@ -4238,6 +4352,25 @@
                                         </p:tgtEl>
                                       </p:cBhvr>
                                     </p:animEffect>
+                                    <p:audio>
+                                      <p:cMediaNode vol="80000">
+                                        <p:cTn id="1005" display="0">
+                                          <p:stCondLst>
+                                            <p:cond delay="0"/>
+                                          </p:stCondLst>
+                                          <p:endCondLst>
+                                            <p:cond evt="onStopAudio" delay="0">
+                                              <p:tgtEl>
+                                                <p:sldTgt/>
+                                              </p:tgtEl>
+                                            </p:cond>
+                                          </p:endCondLst>
+                                        </p:cTn>
+                                        <p:tgtEl>
+                                          <p:sndTgt r:embed="rIdSnd2" name="ding.wav"/>
+                                        </p:tgtEl>
+                                      </p:cMediaNode>
+                                    </p:audio>
                                   </p:childTnLst>
                                 </p:cTn>
                               </p:par>
@@ -4291,6 +4424,25 @@
                                         </p:tgtEl>
                                       </p:cBhvr>
                                     </p:animEffect>
+                                    <p:audio>
+                                      <p:cMediaNode vol="80000">
+                                        <p:cTn id="1006" display="0">
+                                          <p:stCondLst>
+                                            <p:cond delay="0"/>
+                                          </p:stCondLst>
+                                          <p:endCondLst>
+                                            <p:cond evt="onStopAudio" delay="0">
+                                              <p:tgtEl>
+                                                <p:sldTgt/>
+                                              </p:tgtEl>
+                                            </p:cond>
+                                          </p:endCondLst>
+                                        </p:cTn>
+                                        <p:tgtEl>
+                                          <p:sndTgt r:embed="rIdSnd3" name="tick.wav"/>
+                                        </p:tgtEl>
+                                      </p:cMediaNode>
+                                    </p:audio>
                                   </p:childTnLst>
                                 </p:cTn>
                               </p:par>
@@ -4344,6 +4496,25 @@
                                         </p:tgtEl>
                                       </p:cBhvr>
                                     </p:animEffect>
+                                    <p:audio>
+                                      <p:cMediaNode vol="80000">
+                                        <p:cTn id="1007" display="0">
+                                          <p:stCondLst>
+                                            <p:cond delay="0"/>
+                                          </p:stCondLst>
+                                          <p:endCondLst>
+                                            <p:cond evt="onStopAudio" delay="0">
+                                              <p:tgtEl>
+                                                <p:sldTgt/>
+                                              </p:tgtEl>
+                                            </p:cond>
+                                          </p:endCondLst>
+                                        </p:cTn>
+                                        <p:tgtEl>
+                                          <p:sndTgt r:embed="rIdSnd1" name="pop.wav"/>
+                                        </p:tgtEl>
+                                      </p:cMediaNode>
+                                    </p:audio>
                                   </p:childTnLst>
                                 </p:cTn>
                               </p:par>
@@ -4397,6 +4568,25 @@
                                         </p:tgtEl>
                                       </p:cBhvr>
                                     </p:animEffect>
+                                    <p:audio>
+                                      <p:cMediaNode vol="80000">
+                                        <p:cTn id="1008" display="0">
+                                          <p:stCondLst>
+                                            <p:cond delay="0"/>
+                                          </p:stCondLst>
+                                          <p:endCondLst>
+                                            <p:cond evt="onStopAudio" delay="0">
+                                              <p:tgtEl>
+                                                <p:sldTgt/>
+                                              </p:tgtEl>
+                                            </p:cond>
+                                          </p:endCondLst>
+                                        </p:cTn>
+                                        <p:tgtEl>
+                                          <p:sndTgt r:embed="rIdSnd2" name="ding.wav"/>
+                                        </p:tgtEl>
+                                      </p:cMediaNode>
+                                    </p:audio>
                                   </p:childTnLst>
                                 </p:cTn>
                               </p:par>
@@ -4450,6 +4640,25 @@
                                         </p:tgtEl>
                                       </p:cBhvr>
                                     </p:animEffect>
+                                    <p:audio>
+                                      <p:cMediaNode vol="80000">
+                                        <p:cTn id="1009" display="0">
+                                          <p:stCondLst>
+                                            <p:cond delay="0"/>
+                                          </p:stCondLst>
+                                          <p:endCondLst>
+                                            <p:cond evt="onStopAudio" delay="0">
+                                              <p:tgtEl>
+                                                <p:sldTgt/>
+                                              </p:tgtEl>
+                                            </p:cond>
+                                          </p:endCondLst>
+                                        </p:cTn>
+                                        <p:tgtEl>
+                                          <p:sndTgt r:embed="rIdSnd3" name="tick.wav"/>
+                                        </p:tgtEl>
+                                      </p:cMediaNode>
+                                    </p:audio>
                                   </p:childTnLst>
                                 </p:cTn>
                               </p:par>
@@ -4503,6 +4712,25 @@
                                         </p:tgtEl>
                                       </p:cBhvr>
                                     </p:animEffect>
+                                    <p:audio>
+                                      <p:cMediaNode vol="80000">
+                                        <p:cTn id="1010" display="0">
+                                          <p:stCondLst>
+                                            <p:cond delay="0"/>
+                                          </p:stCondLst>
+                                          <p:endCondLst>
+                                            <p:cond evt="onStopAudio" delay="0">
+                                              <p:tgtEl>
+                                                <p:sldTgt/>
+                                              </p:tgtEl>
+                                            </p:cond>
+                                          </p:endCondLst>
+                                        </p:cTn>
+                                        <p:tgtEl>
+                                          <p:sndTgt r:embed="rIdSnd4" name="win.wav"/>
+                                        </p:tgtEl>
+                                      </p:cMediaNode>
+                                    </p:audio>
                                   </p:childTnLst>
                                 </p:cTn>
                               </p:par>
@@ -5330,6 +5558,25 @@
                                         </p:tgtEl>
                                       </p:cBhvr>
                                     </p:animEffect>
+                                    <p:audio>
+                                      <p:cMediaNode vol="80000">
+                                        <p:cTn id="1001" display="0">
+                                          <p:stCondLst>
+                                            <p:cond delay="0"/>
+                                          </p:stCondLst>
+                                          <p:endCondLst>
+                                            <p:cond evt="onStopAudio" delay="0">
+                                              <p:tgtEl>
+                                                <p:sldTgt/>
+                                              </p:tgtEl>
+                                            </p:cond>
+                                          </p:endCondLst>
+                                        </p:cTn>
+                                        <p:tgtEl>
+                                          <p:sndTgt r:embed="rIdSnd1" name="pop.wav"/>
+                                        </p:tgtEl>
+                                      </p:cMediaNode>
+                                    </p:audio>
                                   </p:childTnLst>
                                 </p:cTn>
                               </p:par>
@@ -5383,6 +5630,25 @@
                                         </p:tgtEl>
                                       </p:cBhvr>
                                     </p:animEffect>
+                                    <p:audio>
+                                      <p:cMediaNode vol="80000">
+                                        <p:cTn id="1002" display="0">
+                                          <p:stCondLst>
+                                            <p:cond delay="0"/>
+                                          </p:stCondLst>
+                                          <p:endCondLst>
+                                            <p:cond evt="onStopAudio" delay="0">
+                                              <p:tgtEl>
+                                                <p:sldTgt/>
+                                              </p:tgtEl>
+                                            </p:cond>
+                                          </p:endCondLst>
+                                        </p:cTn>
+                                        <p:tgtEl>
+                                          <p:sndTgt r:embed="rIdSnd2" name="ding.wav"/>
+                                        </p:tgtEl>
+                                      </p:cMediaNode>
+                                    </p:audio>
                                   </p:childTnLst>
                                 </p:cTn>
                               </p:par>
@@ -5436,6 +5702,25 @@
                                         </p:tgtEl>
                                       </p:cBhvr>
                                     </p:animEffect>
+                                    <p:audio>
+                                      <p:cMediaNode vol="80000">
+                                        <p:cTn id="1003" display="0">
+                                          <p:stCondLst>
+                                            <p:cond delay="0"/>
+                                          </p:stCondLst>
+                                          <p:endCondLst>
+                                            <p:cond evt="onStopAudio" delay="0">
+                                              <p:tgtEl>
+                                                <p:sldTgt/>
+                                              </p:tgtEl>
+                                            </p:cond>
+                                          </p:endCondLst>
+                                        </p:cTn>
+                                        <p:tgtEl>
+                                          <p:sndTgt r:embed="rIdSnd3" name="tick.wav"/>
+                                        </p:tgtEl>
+                                      </p:cMediaNode>
+                                    </p:audio>
                                   </p:childTnLst>
                                 </p:cTn>
                               </p:par>
@@ -5489,6 +5774,25 @@
                                         </p:tgtEl>
                                       </p:cBhvr>
                                     </p:animEffect>
+                                    <p:audio>
+                                      <p:cMediaNode vol="80000">
+                                        <p:cTn id="1004" display="0">
+                                          <p:stCondLst>
+                                            <p:cond delay="0"/>
+                                          </p:stCondLst>
+                                          <p:endCondLst>
+                                            <p:cond evt="onStopAudio" delay="0">
+                                              <p:tgtEl>
+                                                <p:sldTgt/>
+                                              </p:tgtEl>
+                                            </p:cond>
+                                          </p:endCondLst>
+                                        </p:cTn>
+                                        <p:tgtEl>
+                                          <p:sndTgt r:embed="rIdSnd1" name="pop.wav"/>
+                                        </p:tgtEl>
+                                      </p:cMediaNode>
+                                    </p:audio>
                                   </p:childTnLst>
                                 </p:cTn>
                               </p:par>
@@ -5542,6 +5846,25 @@
                                         </p:tgtEl>
                                       </p:cBhvr>
                                     </p:animEffect>
+                                    <p:audio>
+                                      <p:cMediaNode vol="80000">
+                                        <p:cTn id="1005" display="0">
+                                          <p:stCondLst>
+                                            <p:cond delay="0"/>
+                                          </p:stCondLst>
+                                          <p:endCondLst>
+                                            <p:cond evt="onStopAudio" delay="0">
+                                              <p:tgtEl>
+                                                <p:sldTgt/>
+                                              </p:tgtEl>
+                                            </p:cond>
+                                          </p:endCondLst>
+                                        </p:cTn>
+                                        <p:tgtEl>
+                                          <p:sndTgt r:embed="rIdSnd2" name="ding.wav"/>
+                                        </p:tgtEl>
+                                      </p:cMediaNode>
+                                    </p:audio>
                                   </p:childTnLst>
                                 </p:cTn>
                               </p:par>
@@ -5595,6 +5918,25 @@
                                         </p:tgtEl>
                                       </p:cBhvr>
                                     </p:animEffect>
+                                    <p:audio>
+                                      <p:cMediaNode vol="80000">
+                                        <p:cTn id="1006" display="0">
+                                          <p:stCondLst>
+                                            <p:cond delay="0"/>
+                                          </p:stCondLst>
+                                          <p:endCondLst>
+                                            <p:cond evt="onStopAudio" delay="0">
+                                              <p:tgtEl>
+                                                <p:sldTgt/>
+                                              </p:tgtEl>
+                                            </p:cond>
+                                          </p:endCondLst>
+                                        </p:cTn>
+                                        <p:tgtEl>
+                                          <p:sndTgt r:embed="rIdSnd3" name="tick.wav"/>
+                                        </p:tgtEl>
+                                      </p:cMediaNode>
+                                    </p:audio>
                                   </p:childTnLst>
                                 </p:cTn>
                               </p:par>
@@ -5648,6 +5990,25 @@
                                         </p:tgtEl>
                                       </p:cBhvr>
                                     </p:animEffect>
+                                    <p:audio>
+                                      <p:cMediaNode vol="80000">
+                                        <p:cTn id="1007" display="0">
+                                          <p:stCondLst>
+                                            <p:cond delay="0"/>
+                                          </p:stCondLst>
+                                          <p:endCondLst>
+                                            <p:cond evt="onStopAudio" delay="0">
+                                              <p:tgtEl>
+                                                <p:sldTgt/>
+                                              </p:tgtEl>
+                                            </p:cond>
+                                          </p:endCondLst>
+                                        </p:cTn>
+                                        <p:tgtEl>
+                                          <p:sndTgt r:embed="rIdSnd1" name="pop.wav"/>
+                                        </p:tgtEl>
+                                      </p:cMediaNode>
+                                    </p:audio>
                                   </p:childTnLst>
                                 </p:cTn>
                               </p:par>
@@ -5701,6 +6062,25 @@
                                         </p:tgtEl>
                                       </p:cBhvr>
                                     </p:animEffect>
+                                    <p:audio>
+                                      <p:cMediaNode vol="80000">
+                                        <p:cTn id="1008" display="0">
+                                          <p:stCondLst>
+                                            <p:cond delay="0"/>
+                                          </p:stCondLst>
+                                          <p:endCondLst>
+                                            <p:cond evt="onStopAudio" delay="0">
+                                              <p:tgtEl>
+                                                <p:sldTgt/>
+                                              </p:tgtEl>
+                                            </p:cond>
+                                          </p:endCondLst>
+                                        </p:cTn>
+                                        <p:tgtEl>
+                                          <p:sndTgt r:embed="rIdSnd2" name="ding.wav"/>
+                                        </p:tgtEl>
+                                      </p:cMediaNode>
+                                    </p:audio>
                                   </p:childTnLst>
                                 </p:cTn>
                               </p:par>
@@ -5754,6 +6134,25 @@
                                         </p:tgtEl>
                                       </p:cBhvr>
                                     </p:animEffect>
+                                    <p:audio>
+                                      <p:cMediaNode vol="80000">
+                                        <p:cTn id="1009" display="0">
+                                          <p:stCondLst>
+                                            <p:cond delay="0"/>
+                                          </p:stCondLst>
+                                          <p:endCondLst>
+                                            <p:cond evt="onStopAudio" delay="0">
+                                              <p:tgtEl>
+                                                <p:sldTgt/>
+                                              </p:tgtEl>
+                                            </p:cond>
+                                          </p:endCondLst>
+                                        </p:cTn>
+                                        <p:tgtEl>
+                                          <p:sndTgt r:embed="rIdSnd3" name="tick.wav"/>
+                                        </p:tgtEl>
+                                      </p:cMediaNode>
+                                    </p:audio>
                                   </p:childTnLst>
                                 </p:cTn>
                               </p:par>
@@ -5807,6 +6206,25 @@
                                         </p:tgtEl>
                                       </p:cBhvr>
                                     </p:animEffect>
+                                    <p:audio>
+                                      <p:cMediaNode vol="80000">
+                                        <p:cTn id="1010" display="0">
+                                          <p:stCondLst>
+                                            <p:cond delay="0"/>
+                                          </p:stCondLst>
+                                          <p:endCondLst>
+                                            <p:cond evt="onStopAudio" delay="0">
+                                              <p:tgtEl>
+                                                <p:sldTgt/>
+                                              </p:tgtEl>
+                                            </p:cond>
+                                          </p:endCondLst>
+                                        </p:cTn>
+                                        <p:tgtEl>
+                                          <p:sndTgt r:embed="rIdSnd4" name="win.wav"/>
+                                        </p:tgtEl>
+                                      </p:cMediaNode>
+                                    </p:audio>
                                   </p:childTnLst>
                                 </p:cTn>
                               </p:par>
@@ -6634,6 +7052,25 @@
                                         </p:tgtEl>
                                       </p:cBhvr>
                                     </p:animEffect>
+                                    <p:audio>
+                                      <p:cMediaNode vol="80000">
+                                        <p:cTn id="1001" display="0">
+                                          <p:stCondLst>
+                                            <p:cond delay="0"/>
+                                          </p:stCondLst>
+                                          <p:endCondLst>
+                                            <p:cond evt="onStopAudio" delay="0">
+                                              <p:tgtEl>
+                                                <p:sldTgt/>
+                                              </p:tgtEl>
+                                            </p:cond>
+                                          </p:endCondLst>
+                                        </p:cTn>
+                                        <p:tgtEl>
+                                          <p:sndTgt r:embed="rIdSnd1" name="pop.wav"/>
+                                        </p:tgtEl>
+                                      </p:cMediaNode>
+                                    </p:audio>
                                   </p:childTnLst>
                                 </p:cTn>
                               </p:par>
@@ -6687,6 +7124,25 @@
                                         </p:tgtEl>
                                       </p:cBhvr>
                                     </p:animEffect>
+                                    <p:audio>
+                                      <p:cMediaNode vol="80000">
+                                        <p:cTn id="1002" display="0">
+                                          <p:stCondLst>
+                                            <p:cond delay="0"/>
+                                          </p:stCondLst>
+                                          <p:endCondLst>
+                                            <p:cond evt="onStopAudio" delay="0">
+                                              <p:tgtEl>
+                                                <p:sldTgt/>
+                                              </p:tgtEl>
+                                            </p:cond>
+                                          </p:endCondLst>
+                                        </p:cTn>
+                                        <p:tgtEl>
+                                          <p:sndTgt r:embed="rIdSnd2" name="ding.wav"/>
+                                        </p:tgtEl>
+                                      </p:cMediaNode>
+                                    </p:audio>
                                   </p:childTnLst>
                                 </p:cTn>
                               </p:par>
@@ -6740,6 +7196,25 @@
                                         </p:tgtEl>
                                       </p:cBhvr>
                                     </p:animEffect>
+                                    <p:audio>
+                                      <p:cMediaNode vol="80000">
+                                        <p:cTn id="1003" display="0">
+                                          <p:stCondLst>
+                                            <p:cond delay="0"/>
+                                          </p:stCondLst>
+                                          <p:endCondLst>
+                                            <p:cond evt="onStopAudio" delay="0">
+                                              <p:tgtEl>
+                                                <p:sldTgt/>
+                                              </p:tgtEl>
+                                            </p:cond>
+                                          </p:endCondLst>
+                                        </p:cTn>
+                                        <p:tgtEl>
+                                          <p:sndTgt r:embed="rIdSnd3" name="tick.wav"/>
+                                        </p:tgtEl>
+                                      </p:cMediaNode>
+                                    </p:audio>
                                   </p:childTnLst>
                                 </p:cTn>
                               </p:par>
@@ -6793,6 +7268,25 @@
                                         </p:tgtEl>
                                       </p:cBhvr>
                                     </p:animEffect>
+                                    <p:audio>
+                                      <p:cMediaNode vol="80000">
+                                        <p:cTn id="1004" display="0">
+                                          <p:stCondLst>
+                                            <p:cond delay="0"/>
+                                          </p:stCondLst>
+                                          <p:endCondLst>
+                                            <p:cond evt="onStopAudio" delay="0">
+                                              <p:tgtEl>
+                                                <p:sldTgt/>
+                                              </p:tgtEl>
+                                            </p:cond>
+                                          </p:endCondLst>
+                                        </p:cTn>
+                                        <p:tgtEl>
+                                          <p:sndTgt r:embed="rIdSnd1" name="pop.wav"/>
+                                        </p:tgtEl>
+                                      </p:cMediaNode>
+                                    </p:audio>
                                   </p:childTnLst>
                                 </p:cTn>
                               </p:par>
@@ -6846,6 +7340,25 @@
                                         </p:tgtEl>
                                       </p:cBhvr>
                                     </p:animEffect>
+                                    <p:audio>
+                                      <p:cMediaNode vol="80000">
+                                        <p:cTn id="1005" display="0">
+                                          <p:stCondLst>
+                                            <p:cond delay="0"/>
+                                          </p:stCondLst>
+                                          <p:endCondLst>
+                                            <p:cond evt="onStopAudio" delay="0">
+                                              <p:tgtEl>
+                                                <p:sldTgt/>
+                                              </p:tgtEl>
+                                            </p:cond>
+                                          </p:endCondLst>
+                                        </p:cTn>
+                                        <p:tgtEl>
+                                          <p:sndTgt r:embed="rIdSnd2" name="ding.wav"/>
+                                        </p:tgtEl>
+                                      </p:cMediaNode>
+                                    </p:audio>
                                   </p:childTnLst>
                                 </p:cTn>
                               </p:par>
@@ -6899,6 +7412,25 @@
                                         </p:tgtEl>
                                       </p:cBhvr>
                                     </p:animEffect>
+                                    <p:audio>
+                                      <p:cMediaNode vol="80000">
+                                        <p:cTn id="1006" display="0">
+                                          <p:stCondLst>
+                                            <p:cond delay="0"/>
+                                          </p:stCondLst>
+                                          <p:endCondLst>
+                                            <p:cond evt="onStopAudio" delay="0">
+                                              <p:tgtEl>
+                                                <p:sldTgt/>
+                                              </p:tgtEl>
+                                            </p:cond>
+                                          </p:endCondLst>
+                                        </p:cTn>
+                                        <p:tgtEl>
+                                          <p:sndTgt r:embed="rIdSnd3" name="tick.wav"/>
+                                        </p:tgtEl>
+                                      </p:cMediaNode>
+                                    </p:audio>
                                   </p:childTnLst>
                                 </p:cTn>
                               </p:par>
@@ -6952,6 +7484,25 @@
                                         </p:tgtEl>
                                       </p:cBhvr>
                                     </p:animEffect>
+                                    <p:audio>
+                                      <p:cMediaNode vol="80000">
+                                        <p:cTn id="1007" display="0">
+                                          <p:stCondLst>
+                                            <p:cond delay="0"/>
+                                          </p:stCondLst>
+                                          <p:endCondLst>
+                                            <p:cond evt="onStopAudio" delay="0">
+                                              <p:tgtEl>
+                                                <p:sldTgt/>
+                                              </p:tgtEl>
+                                            </p:cond>
+                                          </p:endCondLst>
+                                        </p:cTn>
+                                        <p:tgtEl>
+                                          <p:sndTgt r:embed="rIdSnd1" name="pop.wav"/>
+                                        </p:tgtEl>
+                                      </p:cMediaNode>
+                                    </p:audio>
                                   </p:childTnLst>
                                 </p:cTn>
                               </p:par>
@@ -7005,6 +7556,25 @@
                                         </p:tgtEl>
                                       </p:cBhvr>
                                     </p:animEffect>
+                                    <p:audio>
+                                      <p:cMediaNode vol="80000">
+                                        <p:cTn id="1008" display="0">
+                                          <p:stCondLst>
+                                            <p:cond delay="0"/>
+                                          </p:stCondLst>
+                                          <p:endCondLst>
+                                            <p:cond evt="onStopAudio" delay="0">
+                                              <p:tgtEl>
+                                                <p:sldTgt/>
+                                              </p:tgtEl>
+                                            </p:cond>
+                                          </p:endCondLst>
+                                        </p:cTn>
+                                        <p:tgtEl>
+                                          <p:sndTgt r:embed="rIdSnd2" name="ding.wav"/>
+                                        </p:tgtEl>
+                                      </p:cMediaNode>
+                                    </p:audio>
                                   </p:childTnLst>
                                 </p:cTn>
                               </p:par>
@@ -7058,6 +7628,25 @@
                                         </p:tgtEl>
                                       </p:cBhvr>
                                     </p:animEffect>
+                                    <p:audio>
+                                      <p:cMediaNode vol="80000">
+                                        <p:cTn id="1009" display="0">
+                                          <p:stCondLst>
+                                            <p:cond delay="0"/>
+                                          </p:stCondLst>
+                                          <p:endCondLst>
+                                            <p:cond evt="onStopAudio" delay="0">
+                                              <p:tgtEl>
+                                                <p:sldTgt/>
+                                              </p:tgtEl>
+                                            </p:cond>
+                                          </p:endCondLst>
+                                        </p:cTn>
+                                        <p:tgtEl>
+                                          <p:sndTgt r:embed="rIdSnd3" name="tick.wav"/>
+                                        </p:tgtEl>
+                                      </p:cMediaNode>
+                                    </p:audio>
                                   </p:childTnLst>
                                 </p:cTn>
                               </p:par>
@@ -7111,6 +7700,25 @@
                                         </p:tgtEl>
                                       </p:cBhvr>
                                     </p:animEffect>
+                                    <p:audio>
+                                      <p:cMediaNode vol="80000">
+                                        <p:cTn id="1010" display="0">
+                                          <p:stCondLst>
+                                            <p:cond delay="0"/>
+                                          </p:stCondLst>
+                                          <p:endCondLst>
+                                            <p:cond evt="onStopAudio" delay="0">
+                                              <p:tgtEl>
+                                                <p:sldTgt/>
+                                              </p:tgtEl>
+                                            </p:cond>
+                                          </p:endCondLst>
+                                        </p:cTn>
+                                        <p:tgtEl>
+                                          <p:sndTgt r:embed="rIdSnd4" name="win.wav"/>
+                                        </p:tgtEl>
+                                      </p:cMediaNode>
+                                    </p:audio>
                                   </p:childTnLst>
                                 </p:cTn>
                               </p:par>
@@ -7938,6 +8546,25 @@
                                         </p:tgtEl>
                                       </p:cBhvr>
                                     </p:animEffect>
+                                    <p:audio>
+                                      <p:cMediaNode vol="80000">
+                                        <p:cTn id="1001" display="0">
+                                          <p:stCondLst>
+                                            <p:cond delay="0"/>
+                                          </p:stCondLst>
+                                          <p:endCondLst>
+                                            <p:cond evt="onStopAudio" delay="0">
+                                              <p:tgtEl>
+                                                <p:sldTgt/>
+                                              </p:tgtEl>
+                                            </p:cond>
+                                          </p:endCondLst>
+                                        </p:cTn>
+                                        <p:tgtEl>
+                                          <p:sndTgt r:embed="rIdSnd1" name="pop.wav"/>
+                                        </p:tgtEl>
+                                      </p:cMediaNode>
+                                    </p:audio>
                                   </p:childTnLst>
                                 </p:cTn>
                               </p:par>
@@ -7991,6 +8618,25 @@
                                         </p:tgtEl>
                                       </p:cBhvr>
                                     </p:animEffect>
+                                    <p:audio>
+                                      <p:cMediaNode vol="80000">
+                                        <p:cTn id="1002" display="0">
+                                          <p:stCondLst>
+                                            <p:cond delay="0"/>
+                                          </p:stCondLst>
+                                          <p:endCondLst>
+                                            <p:cond evt="onStopAudio" delay="0">
+                                              <p:tgtEl>
+                                                <p:sldTgt/>
+                                              </p:tgtEl>
+                                            </p:cond>
+                                          </p:endCondLst>
+                                        </p:cTn>
+                                        <p:tgtEl>
+                                          <p:sndTgt r:embed="rIdSnd2" name="ding.wav"/>
+                                        </p:tgtEl>
+                                      </p:cMediaNode>
+                                    </p:audio>
                                   </p:childTnLst>
                                 </p:cTn>
                               </p:par>
@@ -8044,6 +8690,25 @@
                                         </p:tgtEl>
                                       </p:cBhvr>
                                     </p:animEffect>
+                                    <p:audio>
+                                      <p:cMediaNode vol="80000">
+                                        <p:cTn id="1003" display="0">
+                                          <p:stCondLst>
+                                            <p:cond delay="0"/>
+                                          </p:stCondLst>
+                                          <p:endCondLst>
+                                            <p:cond evt="onStopAudio" delay="0">
+                                              <p:tgtEl>
+                                                <p:sldTgt/>
+                                              </p:tgtEl>
+                                            </p:cond>
+                                          </p:endCondLst>
+                                        </p:cTn>
+                                        <p:tgtEl>
+                                          <p:sndTgt r:embed="rIdSnd3" name="tick.wav"/>
+                                        </p:tgtEl>
+                                      </p:cMediaNode>
+                                    </p:audio>
                                   </p:childTnLst>
                                 </p:cTn>
                               </p:par>
@@ -8097,6 +8762,25 @@
                                         </p:tgtEl>
                                       </p:cBhvr>
                                     </p:animEffect>
+                                    <p:audio>
+                                      <p:cMediaNode vol="80000">
+                                        <p:cTn id="1004" display="0">
+                                          <p:stCondLst>
+                                            <p:cond delay="0"/>
+                                          </p:stCondLst>
+                                          <p:endCondLst>
+                                            <p:cond evt="onStopAudio" delay="0">
+                                              <p:tgtEl>
+                                                <p:sldTgt/>
+                                              </p:tgtEl>
+                                            </p:cond>
+                                          </p:endCondLst>
+                                        </p:cTn>
+                                        <p:tgtEl>
+                                          <p:sndTgt r:embed="rIdSnd1" name="pop.wav"/>
+                                        </p:tgtEl>
+                                      </p:cMediaNode>
+                                    </p:audio>
                                   </p:childTnLst>
                                 </p:cTn>
                               </p:par>
@@ -8150,6 +8834,25 @@
                                         </p:tgtEl>
                                       </p:cBhvr>
                                     </p:animEffect>
+                                    <p:audio>
+                                      <p:cMediaNode vol="80000">
+                                        <p:cTn id="1005" display="0">
+                                          <p:stCondLst>
+                                            <p:cond delay="0"/>
+                                          </p:stCondLst>
+                                          <p:endCondLst>
+                                            <p:cond evt="onStopAudio" delay="0">
+                                              <p:tgtEl>
+                                                <p:sldTgt/>
+                                              </p:tgtEl>
+                                            </p:cond>
+                                          </p:endCondLst>
+                                        </p:cTn>
+                                        <p:tgtEl>
+                                          <p:sndTgt r:embed="rIdSnd2" name="ding.wav"/>
+                                        </p:tgtEl>
+                                      </p:cMediaNode>
+                                    </p:audio>
                                   </p:childTnLst>
                                 </p:cTn>
                               </p:par>
@@ -8203,6 +8906,25 @@
                                         </p:tgtEl>
                                       </p:cBhvr>
                                     </p:animEffect>
+                                    <p:audio>
+                                      <p:cMediaNode vol="80000">
+                                        <p:cTn id="1006" display="0">
+                                          <p:stCondLst>
+                                            <p:cond delay="0"/>
+                                          </p:stCondLst>
+                                          <p:endCondLst>
+                                            <p:cond evt="onStopAudio" delay="0">
+                                              <p:tgtEl>
+                                                <p:sldTgt/>
+                                              </p:tgtEl>
+                                            </p:cond>
+                                          </p:endCondLst>
+                                        </p:cTn>
+                                        <p:tgtEl>
+                                          <p:sndTgt r:embed="rIdSnd3" name="tick.wav"/>
+                                        </p:tgtEl>
+                                      </p:cMediaNode>
+                                    </p:audio>
                                   </p:childTnLst>
                                 </p:cTn>
                               </p:par>
@@ -8256,6 +8978,25 @@
                                         </p:tgtEl>
                                       </p:cBhvr>
                                     </p:animEffect>
+                                    <p:audio>
+                                      <p:cMediaNode vol="80000">
+                                        <p:cTn id="1007" display="0">
+                                          <p:stCondLst>
+                                            <p:cond delay="0"/>
+                                          </p:stCondLst>
+                                          <p:endCondLst>
+                                            <p:cond evt="onStopAudio" delay="0">
+                                              <p:tgtEl>
+                                                <p:sldTgt/>
+                                              </p:tgtEl>
+                                            </p:cond>
+                                          </p:endCondLst>
+                                        </p:cTn>
+                                        <p:tgtEl>
+                                          <p:sndTgt r:embed="rIdSnd1" name="pop.wav"/>
+                                        </p:tgtEl>
+                                      </p:cMediaNode>
+                                    </p:audio>
                                   </p:childTnLst>
                                 </p:cTn>
                               </p:par>
@@ -8309,6 +9050,25 @@
                                         </p:tgtEl>
                                       </p:cBhvr>
                                     </p:animEffect>
+                                    <p:audio>
+                                      <p:cMediaNode vol="80000">
+                                        <p:cTn id="1008" display="0">
+                                          <p:stCondLst>
+                                            <p:cond delay="0"/>
+                                          </p:stCondLst>
+                                          <p:endCondLst>
+                                            <p:cond evt="onStopAudio" delay="0">
+                                              <p:tgtEl>
+                                                <p:sldTgt/>
+                                              </p:tgtEl>
+                                            </p:cond>
+                                          </p:endCondLst>
+                                        </p:cTn>
+                                        <p:tgtEl>
+                                          <p:sndTgt r:embed="rIdSnd2" name="ding.wav"/>
+                                        </p:tgtEl>
+                                      </p:cMediaNode>
+                                    </p:audio>
                                   </p:childTnLst>
                                 </p:cTn>
                               </p:par>
@@ -8362,6 +9122,25 @@
                                         </p:tgtEl>
                                       </p:cBhvr>
                                     </p:animEffect>
+                                    <p:audio>
+                                      <p:cMediaNode vol="80000">
+                                        <p:cTn id="1009" display="0">
+                                          <p:stCondLst>
+                                            <p:cond delay="0"/>
+                                          </p:stCondLst>
+                                          <p:endCondLst>
+                                            <p:cond evt="onStopAudio" delay="0">
+                                              <p:tgtEl>
+                                                <p:sldTgt/>
+                                              </p:tgtEl>
+                                            </p:cond>
+                                          </p:endCondLst>
+                                        </p:cTn>
+                                        <p:tgtEl>
+                                          <p:sndTgt r:embed="rIdSnd3" name="tick.wav"/>
+                                        </p:tgtEl>
+                                      </p:cMediaNode>
+                                    </p:audio>
                                   </p:childTnLst>
                                 </p:cTn>
                               </p:par>
@@ -8415,6 +9194,25 @@
                                         </p:tgtEl>
                                       </p:cBhvr>
                                     </p:animEffect>
+                                    <p:audio>
+                                      <p:cMediaNode vol="80000">
+                                        <p:cTn id="1010" display="0">
+                                          <p:stCondLst>
+                                            <p:cond delay="0"/>
+                                          </p:stCondLst>
+                                          <p:endCondLst>
+                                            <p:cond evt="onStopAudio" delay="0">
+                                              <p:tgtEl>
+                                                <p:sldTgt/>
+                                              </p:tgtEl>
+                                            </p:cond>
+                                          </p:endCondLst>
+                                        </p:cTn>
+                                        <p:tgtEl>
+                                          <p:sndTgt r:embed="rIdSnd4" name="win.wav"/>
+                                        </p:tgtEl>
+                                      </p:cMediaNode>
+                                    </p:audio>
                                   </p:childTnLst>
                                 </p:cTn>
                               </p:par>
@@ -9242,6 +10040,25 @@
                                         </p:tgtEl>
                                       </p:cBhvr>
                                     </p:animEffect>
+                                    <p:audio>
+                                      <p:cMediaNode vol="80000">
+                                        <p:cTn id="1001" display="0">
+                                          <p:stCondLst>
+                                            <p:cond delay="0"/>
+                                          </p:stCondLst>
+                                          <p:endCondLst>
+                                            <p:cond evt="onStopAudio" delay="0">
+                                              <p:tgtEl>
+                                                <p:sldTgt/>
+                                              </p:tgtEl>
+                                            </p:cond>
+                                          </p:endCondLst>
+                                        </p:cTn>
+                                        <p:tgtEl>
+                                          <p:sndTgt r:embed="rIdSnd1" name="pop.wav"/>
+                                        </p:tgtEl>
+                                      </p:cMediaNode>
+                                    </p:audio>
                                   </p:childTnLst>
                                 </p:cTn>
                               </p:par>
@@ -9295,6 +10112,25 @@
                                         </p:tgtEl>
                                       </p:cBhvr>
                                     </p:animEffect>
+                                    <p:audio>
+                                      <p:cMediaNode vol="80000">
+                                        <p:cTn id="1002" display="0">
+                                          <p:stCondLst>
+                                            <p:cond delay="0"/>
+                                          </p:stCondLst>
+                                          <p:endCondLst>
+                                            <p:cond evt="onStopAudio" delay="0">
+                                              <p:tgtEl>
+                                                <p:sldTgt/>
+                                              </p:tgtEl>
+                                            </p:cond>
+                                          </p:endCondLst>
+                                        </p:cTn>
+                                        <p:tgtEl>
+                                          <p:sndTgt r:embed="rIdSnd2" name="ding.wav"/>
+                                        </p:tgtEl>
+                                      </p:cMediaNode>
+                                    </p:audio>
                                   </p:childTnLst>
                                 </p:cTn>
                               </p:par>
@@ -9348,6 +10184,25 @@
                                         </p:tgtEl>
                                       </p:cBhvr>
                                     </p:animEffect>
+                                    <p:audio>
+                                      <p:cMediaNode vol="80000">
+                                        <p:cTn id="1003" display="0">
+                                          <p:stCondLst>
+                                            <p:cond delay="0"/>
+                                          </p:stCondLst>
+                                          <p:endCondLst>
+                                            <p:cond evt="onStopAudio" delay="0">
+                                              <p:tgtEl>
+                                                <p:sldTgt/>
+                                              </p:tgtEl>
+                                            </p:cond>
+                                          </p:endCondLst>
+                                        </p:cTn>
+                                        <p:tgtEl>
+                                          <p:sndTgt r:embed="rIdSnd3" name="tick.wav"/>
+                                        </p:tgtEl>
+                                      </p:cMediaNode>
+                                    </p:audio>
                                   </p:childTnLst>
                                 </p:cTn>
                               </p:par>
@@ -9401,6 +10256,25 @@
                                         </p:tgtEl>
                                       </p:cBhvr>
                                     </p:animEffect>
+                                    <p:audio>
+                                      <p:cMediaNode vol="80000">
+                                        <p:cTn id="1004" display="0">
+                                          <p:stCondLst>
+                                            <p:cond delay="0"/>
+                                          </p:stCondLst>
+                                          <p:endCondLst>
+                                            <p:cond evt="onStopAudio" delay="0">
+                                              <p:tgtEl>
+                                                <p:sldTgt/>
+                                              </p:tgtEl>
+                                            </p:cond>
+                                          </p:endCondLst>
+                                        </p:cTn>
+                                        <p:tgtEl>
+                                          <p:sndTgt r:embed="rIdSnd1" name="pop.wav"/>
+                                        </p:tgtEl>
+                                      </p:cMediaNode>
+                                    </p:audio>
                                   </p:childTnLst>
                                 </p:cTn>
                               </p:par>
@@ -9454,6 +10328,25 @@
                                         </p:tgtEl>
                                       </p:cBhvr>
                                     </p:animEffect>
+                                    <p:audio>
+                                      <p:cMediaNode vol="80000">
+                                        <p:cTn id="1005" display="0">
+                                          <p:stCondLst>
+                                            <p:cond delay="0"/>
+                                          </p:stCondLst>
+                                          <p:endCondLst>
+                                            <p:cond evt="onStopAudio" delay="0">
+                                              <p:tgtEl>
+                                                <p:sldTgt/>
+                                              </p:tgtEl>
+                                            </p:cond>
+                                          </p:endCondLst>
+                                        </p:cTn>
+                                        <p:tgtEl>
+                                          <p:sndTgt r:embed="rIdSnd2" name="ding.wav"/>
+                                        </p:tgtEl>
+                                      </p:cMediaNode>
+                                    </p:audio>
                                   </p:childTnLst>
                                 </p:cTn>
                               </p:par>
@@ -9507,6 +10400,25 @@
                                         </p:tgtEl>
                                       </p:cBhvr>
                                     </p:animEffect>
+                                    <p:audio>
+                                      <p:cMediaNode vol="80000">
+                                        <p:cTn id="1006" display="0">
+                                          <p:stCondLst>
+                                            <p:cond delay="0"/>
+                                          </p:stCondLst>
+                                          <p:endCondLst>
+                                            <p:cond evt="onStopAudio" delay="0">
+                                              <p:tgtEl>
+                                                <p:sldTgt/>
+                                              </p:tgtEl>
+                                            </p:cond>
+                                          </p:endCondLst>
+                                        </p:cTn>
+                                        <p:tgtEl>
+                                          <p:sndTgt r:embed="rIdSnd3" name="tick.wav"/>
+                                        </p:tgtEl>
+                                      </p:cMediaNode>
+                                    </p:audio>
                                   </p:childTnLst>
                                 </p:cTn>
                               </p:par>
@@ -9560,6 +10472,25 @@
                                         </p:tgtEl>
                                       </p:cBhvr>
                                     </p:animEffect>
+                                    <p:audio>
+                                      <p:cMediaNode vol="80000">
+                                        <p:cTn id="1007" display="0">
+                                          <p:stCondLst>
+                                            <p:cond delay="0"/>
+                                          </p:stCondLst>
+                                          <p:endCondLst>
+                                            <p:cond evt="onStopAudio" delay="0">
+                                              <p:tgtEl>
+                                                <p:sldTgt/>
+                                              </p:tgtEl>
+                                            </p:cond>
+                                          </p:endCondLst>
+                                        </p:cTn>
+                                        <p:tgtEl>
+                                          <p:sndTgt r:embed="rIdSnd1" name="pop.wav"/>
+                                        </p:tgtEl>
+                                      </p:cMediaNode>
+                                    </p:audio>
                                   </p:childTnLst>
                                 </p:cTn>
                               </p:par>
@@ -9613,6 +10544,25 @@
                                         </p:tgtEl>
                                       </p:cBhvr>
                                     </p:animEffect>
+                                    <p:audio>
+                                      <p:cMediaNode vol="80000">
+                                        <p:cTn id="1008" display="0">
+                                          <p:stCondLst>
+                                            <p:cond delay="0"/>
+                                          </p:stCondLst>
+                                          <p:endCondLst>
+                                            <p:cond evt="onStopAudio" delay="0">
+                                              <p:tgtEl>
+                                                <p:sldTgt/>
+                                              </p:tgtEl>
+                                            </p:cond>
+                                          </p:endCondLst>
+                                        </p:cTn>
+                                        <p:tgtEl>
+                                          <p:sndTgt r:embed="rIdSnd2" name="ding.wav"/>
+                                        </p:tgtEl>
+                                      </p:cMediaNode>
+                                    </p:audio>
                                   </p:childTnLst>
                                 </p:cTn>
                               </p:par>
@@ -9666,6 +10616,25 @@
                                         </p:tgtEl>
                                       </p:cBhvr>
                                     </p:animEffect>
+                                    <p:audio>
+                                      <p:cMediaNode vol="80000">
+                                        <p:cTn id="1009" display="0">
+                                          <p:stCondLst>
+                                            <p:cond delay="0"/>
+                                          </p:stCondLst>
+                                          <p:endCondLst>
+                                            <p:cond evt="onStopAudio" delay="0">
+                                              <p:tgtEl>
+                                                <p:sldTgt/>
+                                              </p:tgtEl>
+                                            </p:cond>
+                                          </p:endCondLst>
+                                        </p:cTn>
+                                        <p:tgtEl>
+                                          <p:sndTgt r:embed="rIdSnd3" name="tick.wav"/>
+                                        </p:tgtEl>
+                                      </p:cMediaNode>
+                                    </p:audio>
                                   </p:childTnLst>
                                 </p:cTn>
                               </p:par>
@@ -9719,6 +10688,25 @@
                                         </p:tgtEl>
                                       </p:cBhvr>
                                     </p:animEffect>
+                                    <p:audio>
+                                      <p:cMediaNode vol="80000">
+                                        <p:cTn id="1010" display="0">
+                                          <p:stCondLst>
+                                            <p:cond delay="0"/>
+                                          </p:stCondLst>
+                                          <p:endCondLst>
+                                            <p:cond evt="onStopAudio" delay="0">
+                                              <p:tgtEl>
+                                                <p:sldTgt/>
+                                              </p:tgtEl>
+                                            </p:cond>
+                                          </p:endCondLst>
+                                        </p:cTn>
+                                        <p:tgtEl>
+                                          <p:sndTgt r:embed="rIdSnd4" name="win.wav"/>
+                                        </p:tgtEl>
+                                      </p:cMediaNode>
+                                    </p:audio>
                                   </p:childTnLst>
                                 </p:cTn>
                               </p:par>
@@ -10546,6 +11534,25 @@
                                         </p:tgtEl>
                                       </p:cBhvr>
                                     </p:animEffect>
+                                    <p:audio>
+                                      <p:cMediaNode vol="80000">
+                                        <p:cTn id="1001" display="0">
+                                          <p:stCondLst>
+                                            <p:cond delay="0"/>
+                                          </p:stCondLst>
+                                          <p:endCondLst>
+                                            <p:cond evt="onStopAudio" delay="0">
+                                              <p:tgtEl>
+                                                <p:sldTgt/>
+                                              </p:tgtEl>
+                                            </p:cond>
+                                          </p:endCondLst>
+                                        </p:cTn>
+                                        <p:tgtEl>
+                                          <p:sndTgt r:embed="rIdSnd1" name="pop.wav"/>
+                                        </p:tgtEl>
+                                      </p:cMediaNode>
+                                    </p:audio>
                                   </p:childTnLst>
                                 </p:cTn>
                               </p:par>
@@ -10599,6 +11606,25 @@
                                         </p:tgtEl>
                                       </p:cBhvr>
                                     </p:animEffect>
+                                    <p:audio>
+                                      <p:cMediaNode vol="80000">
+                                        <p:cTn id="1002" display="0">
+                                          <p:stCondLst>
+                                            <p:cond delay="0"/>
+                                          </p:stCondLst>
+                                          <p:endCondLst>
+                                            <p:cond evt="onStopAudio" delay="0">
+                                              <p:tgtEl>
+                                                <p:sldTgt/>
+                                              </p:tgtEl>
+                                            </p:cond>
+                                          </p:endCondLst>
+                                        </p:cTn>
+                                        <p:tgtEl>
+                                          <p:sndTgt r:embed="rIdSnd2" name="ding.wav"/>
+                                        </p:tgtEl>
+                                      </p:cMediaNode>
+                                    </p:audio>
                                   </p:childTnLst>
                                 </p:cTn>
                               </p:par>
@@ -10652,6 +11678,25 @@
                                         </p:tgtEl>
                                       </p:cBhvr>
                                     </p:animEffect>
+                                    <p:audio>
+                                      <p:cMediaNode vol="80000">
+                                        <p:cTn id="1003" display="0">
+                                          <p:stCondLst>
+                                            <p:cond delay="0"/>
+                                          </p:stCondLst>
+                                          <p:endCondLst>
+                                            <p:cond evt="onStopAudio" delay="0">
+                                              <p:tgtEl>
+                                                <p:sldTgt/>
+                                              </p:tgtEl>
+                                            </p:cond>
+                                          </p:endCondLst>
+                                        </p:cTn>
+                                        <p:tgtEl>
+                                          <p:sndTgt r:embed="rIdSnd3" name="tick.wav"/>
+                                        </p:tgtEl>
+                                      </p:cMediaNode>
+                                    </p:audio>
                                   </p:childTnLst>
                                 </p:cTn>
                               </p:par>
@@ -10705,6 +11750,25 @@
                                         </p:tgtEl>
                                       </p:cBhvr>
                                     </p:animEffect>
+                                    <p:audio>
+                                      <p:cMediaNode vol="80000">
+                                        <p:cTn id="1004" display="0">
+                                          <p:stCondLst>
+                                            <p:cond delay="0"/>
+                                          </p:stCondLst>
+                                          <p:endCondLst>
+                                            <p:cond evt="onStopAudio" delay="0">
+                                              <p:tgtEl>
+                                                <p:sldTgt/>
+                                              </p:tgtEl>
+                                            </p:cond>
+                                          </p:endCondLst>
+                                        </p:cTn>
+                                        <p:tgtEl>
+                                          <p:sndTgt r:embed="rIdSnd1" name="pop.wav"/>
+                                        </p:tgtEl>
+                                      </p:cMediaNode>
+                                    </p:audio>
                                   </p:childTnLst>
                                 </p:cTn>
                               </p:par>
@@ -10758,6 +11822,25 @@
                                         </p:tgtEl>
                                       </p:cBhvr>
                                     </p:animEffect>
+                                    <p:audio>
+                                      <p:cMediaNode vol="80000">
+                                        <p:cTn id="1005" display="0">
+                                          <p:stCondLst>
+                                            <p:cond delay="0"/>
+                                          </p:stCondLst>
+                                          <p:endCondLst>
+                                            <p:cond evt="onStopAudio" delay="0">
+                                              <p:tgtEl>
+                                                <p:sldTgt/>
+                                              </p:tgtEl>
+                                            </p:cond>
+                                          </p:endCondLst>
+                                        </p:cTn>
+                                        <p:tgtEl>
+                                          <p:sndTgt r:embed="rIdSnd2" name="ding.wav"/>
+                                        </p:tgtEl>
+                                      </p:cMediaNode>
+                                    </p:audio>
                                   </p:childTnLst>
                                 </p:cTn>
                               </p:par>
@@ -10811,6 +11894,25 @@
                                         </p:tgtEl>
                                       </p:cBhvr>
                                     </p:animEffect>
+                                    <p:audio>
+                                      <p:cMediaNode vol="80000">
+                                        <p:cTn id="1006" display="0">
+                                          <p:stCondLst>
+                                            <p:cond delay="0"/>
+                                          </p:stCondLst>
+                                          <p:endCondLst>
+                                            <p:cond evt="onStopAudio" delay="0">
+                                              <p:tgtEl>
+                                                <p:sldTgt/>
+                                              </p:tgtEl>
+                                            </p:cond>
+                                          </p:endCondLst>
+                                        </p:cTn>
+                                        <p:tgtEl>
+                                          <p:sndTgt r:embed="rIdSnd3" name="tick.wav"/>
+                                        </p:tgtEl>
+                                      </p:cMediaNode>
+                                    </p:audio>
                                   </p:childTnLst>
                                 </p:cTn>
                               </p:par>
@@ -10864,6 +11966,25 @@
                                         </p:tgtEl>
                                       </p:cBhvr>
                                     </p:animEffect>
+                                    <p:audio>
+                                      <p:cMediaNode vol="80000">
+                                        <p:cTn id="1007" display="0">
+                                          <p:stCondLst>
+                                            <p:cond delay="0"/>
+                                          </p:stCondLst>
+                                          <p:endCondLst>
+                                            <p:cond evt="onStopAudio" delay="0">
+                                              <p:tgtEl>
+                                                <p:sldTgt/>
+                                              </p:tgtEl>
+                                            </p:cond>
+                                          </p:endCondLst>
+                                        </p:cTn>
+                                        <p:tgtEl>
+                                          <p:sndTgt r:embed="rIdSnd1" name="pop.wav"/>
+                                        </p:tgtEl>
+                                      </p:cMediaNode>
+                                    </p:audio>
                                   </p:childTnLst>
                                 </p:cTn>
                               </p:par>
@@ -10917,6 +12038,25 @@
                                         </p:tgtEl>
                                       </p:cBhvr>
                                     </p:animEffect>
+                                    <p:audio>
+                                      <p:cMediaNode vol="80000">
+                                        <p:cTn id="1008" display="0">
+                                          <p:stCondLst>
+                                            <p:cond delay="0"/>
+                                          </p:stCondLst>
+                                          <p:endCondLst>
+                                            <p:cond evt="onStopAudio" delay="0">
+                                              <p:tgtEl>
+                                                <p:sldTgt/>
+                                              </p:tgtEl>
+                                            </p:cond>
+                                          </p:endCondLst>
+                                        </p:cTn>
+                                        <p:tgtEl>
+                                          <p:sndTgt r:embed="rIdSnd2" name="ding.wav"/>
+                                        </p:tgtEl>
+                                      </p:cMediaNode>
+                                    </p:audio>
                                   </p:childTnLst>
                                 </p:cTn>
                               </p:par>
@@ -10970,6 +12110,25 @@
                                         </p:tgtEl>
                                       </p:cBhvr>
                                     </p:animEffect>
+                                    <p:audio>
+                                      <p:cMediaNode vol="80000">
+                                        <p:cTn id="1009" display="0">
+                                          <p:stCondLst>
+                                            <p:cond delay="0"/>
+                                          </p:stCondLst>
+                                          <p:endCondLst>
+                                            <p:cond evt="onStopAudio" delay="0">
+                                              <p:tgtEl>
+                                                <p:sldTgt/>
+                                              </p:tgtEl>
+                                            </p:cond>
+                                          </p:endCondLst>
+                                        </p:cTn>
+                                        <p:tgtEl>
+                                          <p:sndTgt r:embed="rIdSnd3" name="tick.wav"/>
+                                        </p:tgtEl>
+                                      </p:cMediaNode>
+                                    </p:audio>
                                   </p:childTnLst>
                                 </p:cTn>
                               </p:par>
@@ -11023,6 +12182,25 @@
                                         </p:tgtEl>
                                       </p:cBhvr>
                                     </p:animEffect>
+                                    <p:audio>
+                                      <p:cMediaNode vol="80000">
+                                        <p:cTn id="1010" display="0">
+                                          <p:stCondLst>
+                                            <p:cond delay="0"/>
+                                          </p:stCondLst>
+                                          <p:endCondLst>
+                                            <p:cond evt="onStopAudio" delay="0">
+                                              <p:tgtEl>
+                                                <p:sldTgt/>
+                                              </p:tgtEl>
+                                            </p:cond>
+                                          </p:endCondLst>
+                                        </p:cTn>
+                                        <p:tgtEl>
+                                          <p:sndTgt r:embed="rIdSnd4" name="win.wav"/>
+                                        </p:tgtEl>
+                                      </p:cMediaNode>
+                                    </p:audio>
                                   </p:childTnLst>
                                 </p:cTn>
                               </p:par>
@@ -11722,6 +12900,25 @@
                                         </p:tgtEl>
                                       </p:cBhvr>
                                     </p:animEffect>
+                                    <p:audio>
+                                      <p:cMediaNode vol="80000">
+                                        <p:cTn id="1001" display="0">
+                                          <p:stCondLst>
+                                            <p:cond delay="0"/>
+                                          </p:stCondLst>
+                                          <p:endCondLst>
+                                            <p:cond evt="onStopAudio" delay="0">
+                                              <p:tgtEl>
+                                                <p:sldTgt/>
+                                              </p:tgtEl>
+                                            </p:cond>
+                                          </p:endCondLst>
+                                        </p:cTn>
+                                        <p:tgtEl>
+                                          <p:sndTgt r:embed="rIdSnd1" name="pop.wav"/>
+                                        </p:tgtEl>
+                                      </p:cMediaNode>
+                                    </p:audio>
                                   </p:childTnLst>
                                 </p:cTn>
                               </p:par>
@@ -11775,6 +12972,25 @@
                                         </p:tgtEl>
                                       </p:cBhvr>
                                     </p:animEffect>
+                                    <p:audio>
+                                      <p:cMediaNode vol="80000">
+                                        <p:cTn id="1002" display="0">
+                                          <p:stCondLst>
+                                            <p:cond delay="0"/>
+                                          </p:stCondLst>
+                                          <p:endCondLst>
+                                            <p:cond evt="onStopAudio" delay="0">
+                                              <p:tgtEl>
+                                                <p:sldTgt/>
+                                              </p:tgtEl>
+                                            </p:cond>
+                                          </p:endCondLst>
+                                        </p:cTn>
+                                        <p:tgtEl>
+                                          <p:sndTgt r:embed="rIdSnd2" name="ding.wav"/>
+                                        </p:tgtEl>
+                                      </p:cMediaNode>
+                                    </p:audio>
                                   </p:childTnLst>
                                 </p:cTn>
                               </p:par>
@@ -11828,6 +13044,25 @@
                                         </p:tgtEl>
                                       </p:cBhvr>
                                     </p:animEffect>
+                                    <p:audio>
+                                      <p:cMediaNode vol="80000">
+                                        <p:cTn id="1003" display="0">
+                                          <p:stCondLst>
+                                            <p:cond delay="0"/>
+                                          </p:stCondLst>
+                                          <p:endCondLst>
+                                            <p:cond evt="onStopAudio" delay="0">
+                                              <p:tgtEl>
+                                                <p:sldTgt/>
+                                              </p:tgtEl>
+                                            </p:cond>
+                                          </p:endCondLst>
+                                        </p:cTn>
+                                        <p:tgtEl>
+                                          <p:sndTgt r:embed="rIdSnd3" name="tick.wav"/>
+                                        </p:tgtEl>
+                                      </p:cMediaNode>
+                                    </p:audio>
                                   </p:childTnLst>
                                 </p:cTn>
                               </p:par>
@@ -11881,6 +13116,25 @@
                                         </p:tgtEl>
                                       </p:cBhvr>
                                     </p:animEffect>
+                                    <p:audio>
+                                      <p:cMediaNode vol="80000">
+                                        <p:cTn id="1004" display="0">
+                                          <p:stCondLst>
+                                            <p:cond delay="0"/>
+                                          </p:stCondLst>
+                                          <p:endCondLst>
+                                            <p:cond evt="onStopAudio" delay="0">
+                                              <p:tgtEl>
+                                                <p:sldTgt/>
+                                              </p:tgtEl>
+                                            </p:cond>
+                                          </p:endCondLst>
+                                        </p:cTn>
+                                        <p:tgtEl>
+                                          <p:sndTgt r:embed="rIdSnd1" name="pop.wav"/>
+                                        </p:tgtEl>
+                                      </p:cMediaNode>
+                                    </p:audio>
                                   </p:childTnLst>
                                 </p:cTn>
                               </p:par>
@@ -11934,6 +13188,25 @@
                                         </p:tgtEl>
                                       </p:cBhvr>
                                     </p:animEffect>
+                                    <p:audio>
+                                      <p:cMediaNode vol="80000">
+                                        <p:cTn id="1005" display="0">
+                                          <p:stCondLst>
+                                            <p:cond delay="0"/>
+                                          </p:stCondLst>
+                                          <p:endCondLst>
+                                            <p:cond evt="onStopAudio" delay="0">
+                                              <p:tgtEl>
+                                                <p:sldTgt/>
+                                              </p:tgtEl>
+                                            </p:cond>
+                                          </p:endCondLst>
+                                        </p:cTn>
+                                        <p:tgtEl>
+                                          <p:sndTgt r:embed="rIdSnd2" name="ding.wav"/>
+                                        </p:tgtEl>
+                                      </p:cMediaNode>
+                                    </p:audio>
                                   </p:childTnLst>
                                 </p:cTn>
                               </p:par>
@@ -11987,6 +13260,25 @@
                                         </p:tgtEl>
                                       </p:cBhvr>
                                     </p:animEffect>
+                                    <p:audio>
+                                      <p:cMediaNode vol="80000">
+                                        <p:cTn id="1006" display="0">
+                                          <p:stCondLst>
+                                            <p:cond delay="0"/>
+                                          </p:stCondLst>
+                                          <p:endCondLst>
+                                            <p:cond evt="onStopAudio" delay="0">
+                                              <p:tgtEl>
+                                                <p:sldTgt/>
+                                              </p:tgtEl>
+                                            </p:cond>
+                                          </p:endCondLst>
+                                        </p:cTn>
+                                        <p:tgtEl>
+                                          <p:sndTgt r:embed="rIdSnd3" name="tick.wav"/>
+                                        </p:tgtEl>
+                                      </p:cMediaNode>
+                                    </p:audio>
                                   </p:childTnLst>
                                 </p:cTn>
                               </p:par>
@@ -12040,6 +13332,25 @@
                                         </p:tgtEl>
                                       </p:cBhvr>
                                     </p:animEffect>
+                                    <p:audio>
+                                      <p:cMediaNode vol="80000">
+                                        <p:cTn id="1007" display="0">
+                                          <p:stCondLst>
+                                            <p:cond delay="0"/>
+                                          </p:stCondLst>
+                                          <p:endCondLst>
+                                            <p:cond evt="onStopAudio" delay="0">
+                                              <p:tgtEl>
+                                                <p:sldTgt/>
+                                              </p:tgtEl>
+                                            </p:cond>
+                                          </p:endCondLst>
+                                        </p:cTn>
+                                        <p:tgtEl>
+                                          <p:sndTgt r:embed="rIdSnd4" name="win.wav"/>
+                                        </p:tgtEl>
+                                      </p:cMediaNode>
+                                    </p:audio>
                                   </p:childTnLst>
                                 </p:cTn>
                               </p:par>
@@ -12736,6 +14047,25 @@
                                         </p:tgtEl>
                                       </p:cBhvr>
                                     </p:animEffect>
+                                    <p:audio>
+                                      <p:cMediaNode vol="80000">
+                                        <p:cTn id="1001" display="0">
+                                          <p:stCondLst>
+                                            <p:cond delay="0"/>
+                                          </p:stCondLst>
+                                          <p:endCondLst>
+                                            <p:cond evt="onStopAudio" delay="0">
+                                              <p:tgtEl>
+                                                <p:sldTgt/>
+                                              </p:tgtEl>
+                                            </p:cond>
+                                          </p:endCondLst>
+                                        </p:cTn>
+                                        <p:tgtEl>
+                                          <p:sndTgt r:embed="rIdSnd1" name="pop.wav"/>
+                                        </p:tgtEl>
+                                      </p:cMediaNode>
+                                    </p:audio>
                                   </p:childTnLst>
                                 </p:cTn>
                               </p:par>
@@ -12789,6 +14119,25 @@
                                         </p:tgtEl>
                                       </p:cBhvr>
                                     </p:animEffect>
+                                    <p:audio>
+                                      <p:cMediaNode vol="80000">
+                                        <p:cTn id="1002" display="0">
+                                          <p:stCondLst>
+                                            <p:cond delay="0"/>
+                                          </p:stCondLst>
+                                          <p:endCondLst>
+                                            <p:cond evt="onStopAudio" delay="0">
+                                              <p:tgtEl>
+                                                <p:sldTgt/>
+                                              </p:tgtEl>
+                                            </p:cond>
+                                          </p:endCondLst>
+                                        </p:cTn>
+                                        <p:tgtEl>
+                                          <p:sndTgt r:embed="rIdSnd2" name="ding.wav"/>
+                                        </p:tgtEl>
+                                      </p:cMediaNode>
+                                    </p:audio>
                                   </p:childTnLst>
                                 </p:cTn>
                               </p:par>
@@ -12842,6 +14191,25 @@
                                         </p:tgtEl>
                                       </p:cBhvr>
                                     </p:animEffect>
+                                    <p:audio>
+                                      <p:cMediaNode vol="80000">
+                                        <p:cTn id="1003" display="0">
+                                          <p:stCondLst>
+                                            <p:cond delay="0"/>
+                                          </p:stCondLst>
+                                          <p:endCondLst>
+                                            <p:cond evt="onStopAudio" delay="0">
+                                              <p:tgtEl>
+                                                <p:sldTgt/>
+                                              </p:tgtEl>
+                                            </p:cond>
+                                          </p:endCondLst>
+                                        </p:cTn>
+                                        <p:tgtEl>
+                                          <p:sndTgt r:embed="rIdSnd3" name="tick.wav"/>
+                                        </p:tgtEl>
+                                      </p:cMediaNode>
+                                    </p:audio>
                                   </p:childTnLst>
                                 </p:cTn>
                               </p:par>
@@ -12895,6 +14263,25 @@
                                         </p:tgtEl>
                                       </p:cBhvr>
                                     </p:animEffect>
+                                    <p:audio>
+                                      <p:cMediaNode vol="80000">
+                                        <p:cTn id="1004" display="0">
+                                          <p:stCondLst>
+                                            <p:cond delay="0"/>
+                                          </p:stCondLst>
+                                          <p:endCondLst>
+                                            <p:cond evt="onStopAudio" delay="0">
+                                              <p:tgtEl>
+                                                <p:sldTgt/>
+                                              </p:tgtEl>
+                                            </p:cond>
+                                          </p:endCondLst>
+                                        </p:cTn>
+                                        <p:tgtEl>
+                                          <p:sndTgt r:embed="rIdSnd1" name="pop.wav"/>
+                                        </p:tgtEl>
+                                      </p:cMediaNode>
+                                    </p:audio>
                                   </p:childTnLst>
                                 </p:cTn>
                               </p:par>
@@ -12948,6 +14335,25 @@
                                         </p:tgtEl>
                                       </p:cBhvr>
                                     </p:animEffect>
+                                    <p:audio>
+                                      <p:cMediaNode vol="80000">
+                                        <p:cTn id="1005" display="0">
+                                          <p:stCondLst>
+                                            <p:cond delay="0"/>
+                                          </p:stCondLst>
+                                          <p:endCondLst>
+                                            <p:cond evt="onStopAudio" delay="0">
+                                              <p:tgtEl>
+                                                <p:sldTgt/>
+                                              </p:tgtEl>
+                                            </p:cond>
+                                          </p:endCondLst>
+                                        </p:cTn>
+                                        <p:tgtEl>
+                                          <p:sndTgt r:embed="rIdSnd2" name="ding.wav"/>
+                                        </p:tgtEl>
+                                      </p:cMediaNode>
+                                    </p:audio>
                                   </p:childTnLst>
                                 </p:cTn>
                               </p:par>
@@ -13001,6 +14407,25 @@
                                         </p:tgtEl>
                                       </p:cBhvr>
                                     </p:animEffect>
+                                    <p:audio>
+                                      <p:cMediaNode vol="80000">
+                                        <p:cTn id="1006" display="0">
+                                          <p:stCondLst>
+                                            <p:cond delay="0"/>
+                                          </p:stCondLst>
+                                          <p:endCondLst>
+                                            <p:cond evt="onStopAudio" delay="0">
+                                              <p:tgtEl>
+                                                <p:sldTgt/>
+                                              </p:tgtEl>
+                                            </p:cond>
+                                          </p:endCondLst>
+                                        </p:cTn>
+                                        <p:tgtEl>
+                                          <p:sndTgt r:embed="rIdSnd3" name="tick.wav"/>
+                                        </p:tgtEl>
+                                      </p:cMediaNode>
+                                    </p:audio>
                                   </p:childTnLst>
                                 </p:cTn>
                               </p:par>
@@ -13054,6 +14479,25 @@
                                         </p:tgtEl>
                                       </p:cBhvr>
                                     </p:animEffect>
+                                    <p:audio>
+                                      <p:cMediaNode vol="80000">
+                                        <p:cTn id="1007" display="0">
+                                          <p:stCondLst>
+                                            <p:cond delay="0"/>
+                                          </p:stCondLst>
+                                          <p:endCondLst>
+                                            <p:cond evt="onStopAudio" delay="0">
+                                              <p:tgtEl>
+                                                <p:sldTgt/>
+                                              </p:tgtEl>
+                                            </p:cond>
+                                          </p:endCondLst>
+                                        </p:cTn>
+                                        <p:tgtEl>
+                                          <p:sndTgt r:embed="rIdSnd4" name="win.wav"/>
+                                        </p:tgtEl>
+                                      </p:cMediaNode>
+                                    </p:audio>
                                   </p:childTnLst>
                                 </p:cTn>
                               </p:par>
@@ -13750,6 +15194,25 @@
                                         </p:tgtEl>
                                       </p:cBhvr>
                                     </p:animEffect>
+                                    <p:audio>
+                                      <p:cMediaNode vol="80000">
+                                        <p:cTn id="1001" display="0">
+                                          <p:stCondLst>
+                                            <p:cond delay="0"/>
+                                          </p:stCondLst>
+                                          <p:endCondLst>
+                                            <p:cond evt="onStopAudio" delay="0">
+                                              <p:tgtEl>
+                                                <p:sldTgt/>
+                                              </p:tgtEl>
+                                            </p:cond>
+                                          </p:endCondLst>
+                                        </p:cTn>
+                                        <p:tgtEl>
+                                          <p:sndTgt r:embed="rIdSnd1" name="pop.wav"/>
+                                        </p:tgtEl>
+                                      </p:cMediaNode>
+                                    </p:audio>
                                   </p:childTnLst>
                                 </p:cTn>
                               </p:par>
@@ -13803,6 +15266,25 @@
                                         </p:tgtEl>
                                       </p:cBhvr>
                                     </p:animEffect>
+                                    <p:audio>
+                                      <p:cMediaNode vol="80000">
+                                        <p:cTn id="1002" display="0">
+                                          <p:stCondLst>
+                                            <p:cond delay="0"/>
+                                          </p:stCondLst>
+                                          <p:endCondLst>
+                                            <p:cond evt="onStopAudio" delay="0">
+                                              <p:tgtEl>
+                                                <p:sldTgt/>
+                                              </p:tgtEl>
+                                            </p:cond>
+                                          </p:endCondLst>
+                                        </p:cTn>
+                                        <p:tgtEl>
+                                          <p:sndTgt r:embed="rIdSnd2" name="ding.wav"/>
+                                        </p:tgtEl>
+                                      </p:cMediaNode>
+                                    </p:audio>
                                   </p:childTnLst>
                                 </p:cTn>
                               </p:par>
@@ -13856,6 +15338,25 @@
                                         </p:tgtEl>
                                       </p:cBhvr>
                                     </p:animEffect>
+                                    <p:audio>
+                                      <p:cMediaNode vol="80000">
+                                        <p:cTn id="1003" display="0">
+                                          <p:stCondLst>
+                                            <p:cond delay="0"/>
+                                          </p:stCondLst>
+                                          <p:endCondLst>
+                                            <p:cond evt="onStopAudio" delay="0">
+                                              <p:tgtEl>
+                                                <p:sldTgt/>
+                                              </p:tgtEl>
+                                            </p:cond>
+                                          </p:endCondLst>
+                                        </p:cTn>
+                                        <p:tgtEl>
+                                          <p:sndTgt r:embed="rIdSnd3" name="tick.wav"/>
+                                        </p:tgtEl>
+                                      </p:cMediaNode>
+                                    </p:audio>
                                   </p:childTnLst>
                                 </p:cTn>
                               </p:par>
@@ -13909,6 +15410,25 @@
                                         </p:tgtEl>
                                       </p:cBhvr>
                                     </p:animEffect>
+                                    <p:audio>
+                                      <p:cMediaNode vol="80000">
+                                        <p:cTn id="1004" display="0">
+                                          <p:stCondLst>
+                                            <p:cond delay="0"/>
+                                          </p:stCondLst>
+                                          <p:endCondLst>
+                                            <p:cond evt="onStopAudio" delay="0">
+                                              <p:tgtEl>
+                                                <p:sldTgt/>
+                                              </p:tgtEl>
+                                            </p:cond>
+                                          </p:endCondLst>
+                                        </p:cTn>
+                                        <p:tgtEl>
+                                          <p:sndTgt r:embed="rIdSnd1" name="pop.wav"/>
+                                        </p:tgtEl>
+                                      </p:cMediaNode>
+                                    </p:audio>
                                   </p:childTnLst>
                                 </p:cTn>
                               </p:par>
@@ -13962,6 +15482,25 @@
                                         </p:tgtEl>
                                       </p:cBhvr>
                                     </p:animEffect>
+                                    <p:audio>
+                                      <p:cMediaNode vol="80000">
+                                        <p:cTn id="1005" display="0">
+                                          <p:stCondLst>
+                                            <p:cond delay="0"/>
+                                          </p:stCondLst>
+                                          <p:endCondLst>
+                                            <p:cond evt="onStopAudio" delay="0">
+                                              <p:tgtEl>
+                                                <p:sldTgt/>
+                                              </p:tgtEl>
+                                            </p:cond>
+                                          </p:endCondLst>
+                                        </p:cTn>
+                                        <p:tgtEl>
+                                          <p:sndTgt r:embed="rIdSnd2" name="ding.wav"/>
+                                        </p:tgtEl>
+                                      </p:cMediaNode>
+                                    </p:audio>
                                   </p:childTnLst>
                                 </p:cTn>
                               </p:par>
@@ -14015,6 +15554,25 @@
                                         </p:tgtEl>
                                       </p:cBhvr>
                                     </p:animEffect>
+                                    <p:audio>
+                                      <p:cMediaNode vol="80000">
+                                        <p:cTn id="1006" display="0">
+                                          <p:stCondLst>
+                                            <p:cond delay="0"/>
+                                          </p:stCondLst>
+                                          <p:endCondLst>
+                                            <p:cond evt="onStopAudio" delay="0">
+                                              <p:tgtEl>
+                                                <p:sldTgt/>
+                                              </p:tgtEl>
+                                            </p:cond>
+                                          </p:endCondLst>
+                                        </p:cTn>
+                                        <p:tgtEl>
+                                          <p:sndTgt r:embed="rIdSnd3" name="tick.wav"/>
+                                        </p:tgtEl>
+                                      </p:cMediaNode>
+                                    </p:audio>
                                   </p:childTnLst>
                                 </p:cTn>
                               </p:par>
@@ -14068,6 +15626,25 @@
                                         </p:tgtEl>
                                       </p:cBhvr>
                                     </p:animEffect>
+                                    <p:audio>
+                                      <p:cMediaNode vol="80000">
+                                        <p:cTn id="1007" display="0">
+                                          <p:stCondLst>
+                                            <p:cond delay="0"/>
+                                          </p:stCondLst>
+                                          <p:endCondLst>
+                                            <p:cond evt="onStopAudio" delay="0">
+                                              <p:tgtEl>
+                                                <p:sldTgt/>
+                                              </p:tgtEl>
+                                            </p:cond>
+                                          </p:endCondLst>
+                                        </p:cTn>
+                                        <p:tgtEl>
+                                          <p:sndTgt r:embed="rIdSnd4" name="win.wav"/>
+                                        </p:tgtEl>
+                                      </p:cMediaNode>
+                                    </p:audio>
                                   </p:childTnLst>
                                 </p:cTn>
                               </p:par>
@@ -14764,6 +16341,25 @@
                                         </p:tgtEl>
                                       </p:cBhvr>
                                     </p:animEffect>
+                                    <p:audio>
+                                      <p:cMediaNode vol="80000">
+                                        <p:cTn id="1001" display="0">
+                                          <p:stCondLst>
+                                            <p:cond delay="0"/>
+                                          </p:stCondLst>
+                                          <p:endCondLst>
+                                            <p:cond evt="onStopAudio" delay="0">
+                                              <p:tgtEl>
+                                                <p:sldTgt/>
+                                              </p:tgtEl>
+                                            </p:cond>
+                                          </p:endCondLst>
+                                        </p:cTn>
+                                        <p:tgtEl>
+                                          <p:sndTgt r:embed="rIdSnd1" name="pop.wav"/>
+                                        </p:tgtEl>
+                                      </p:cMediaNode>
+                                    </p:audio>
                                   </p:childTnLst>
                                 </p:cTn>
                               </p:par>
@@ -14817,6 +16413,25 @@
                                         </p:tgtEl>
                                       </p:cBhvr>
                                     </p:animEffect>
+                                    <p:audio>
+                                      <p:cMediaNode vol="80000">
+                                        <p:cTn id="1002" display="0">
+                                          <p:stCondLst>
+                                            <p:cond delay="0"/>
+                                          </p:stCondLst>
+                                          <p:endCondLst>
+                                            <p:cond evt="onStopAudio" delay="0">
+                                              <p:tgtEl>
+                                                <p:sldTgt/>
+                                              </p:tgtEl>
+                                            </p:cond>
+                                          </p:endCondLst>
+                                        </p:cTn>
+                                        <p:tgtEl>
+                                          <p:sndTgt r:embed="rIdSnd2" name="ding.wav"/>
+                                        </p:tgtEl>
+                                      </p:cMediaNode>
+                                    </p:audio>
                                   </p:childTnLst>
                                 </p:cTn>
                               </p:par>
@@ -14870,6 +16485,25 @@
                                         </p:tgtEl>
                                       </p:cBhvr>
                                     </p:animEffect>
+                                    <p:audio>
+                                      <p:cMediaNode vol="80000">
+                                        <p:cTn id="1003" display="0">
+                                          <p:stCondLst>
+                                            <p:cond delay="0"/>
+                                          </p:stCondLst>
+                                          <p:endCondLst>
+                                            <p:cond evt="onStopAudio" delay="0">
+                                              <p:tgtEl>
+                                                <p:sldTgt/>
+                                              </p:tgtEl>
+                                            </p:cond>
+                                          </p:endCondLst>
+                                        </p:cTn>
+                                        <p:tgtEl>
+                                          <p:sndTgt r:embed="rIdSnd3" name="tick.wav"/>
+                                        </p:tgtEl>
+                                      </p:cMediaNode>
+                                    </p:audio>
                                   </p:childTnLst>
                                 </p:cTn>
                               </p:par>
@@ -14923,6 +16557,25 @@
                                         </p:tgtEl>
                                       </p:cBhvr>
                                     </p:animEffect>
+                                    <p:audio>
+                                      <p:cMediaNode vol="80000">
+                                        <p:cTn id="1004" display="0">
+                                          <p:stCondLst>
+                                            <p:cond delay="0"/>
+                                          </p:stCondLst>
+                                          <p:endCondLst>
+                                            <p:cond evt="onStopAudio" delay="0">
+                                              <p:tgtEl>
+                                                <p:sldTgt/>
+                                              </p:tgtEl>
+                                            </p:cond>
+                                          </p:endCondLst>
+                                        </p:cTn>
+                                        <p:tgtEl>
+                                          <p:sndTgt r:embed="rIdSnd1" name="pop.wav"/>
+                                        </p:tgtEl>
+                                      </p:cMediaNode>
+                                    </p:audio>
                                   </p:childTnLst>
                                 </p:cTn>
                               </p:par>
@@ -14976,6 +16629,25 @@
                                         </p:tgtEl>
                                       </p:cBhvr>
                                     </p:animEffect>
+                                    <p:audio>
+                                      <p:cMediaNode vol="80000">
+                                        <p:cTn id="1005" display="0">
+                                          <p:stCondLst>
+                                            <p:cond delay="0"/>
+                                          </p:stCondLst>
+                                          <p:endCondLst>
+                                            <p:cond evt="onStopAudio" delay="0">
+                                              <p:tgtEl>
+                                                <p:sldTgt/>
+                                              </p:tgtEl>
+                                            </p:cond>
+                                          </p:endCondLst>
+                                        </p:cTn>
+                                        <p:tgtEl>
+                                          <p:sndTgt r:embed="rIdSnd2" name="ding.wav"/>
+                                        </p:tgtEl>
+                                      </p:cMediaNode>
+                                    </p:audio>
                                   </p:childTnLst>
                                 </p:cTn>
                               </p:par>
@@ -15029,6 +16701,25 @@
                                         </p:tgtEl>
                                       </p:cBhvr>
                                     </p:animEffect>
+                                    <p:audio>
+                                      <p:cMediaNode vol="80000">
+                                        <p:cTn id="1006" display="0">
+                                          <p:stCondLst>
+                                            <p:cond delay="0"/>
+                                          </p:stCondLst>
+                                          <p:endCondLst>
+                                            <p:cond evt="onStopAudio" delay="0">
+                                              <p:tgtEl>
+                                                <p:sldTgt/>
+                                              </p:tgtEl>
+                                            </p:cond>
+                                          </p:endCondLst>
+                                        </p:cTn>
+                                        <p:tgtEl>
+                                          <p:sndTgt r:embed="rIdSnd3" name="tick.wav"/>
+                                        </p:tgtEl>
+                                      </p:cMediaNode>
+                                    </p:audio>
                                   </p:childTnLst>
                                 </p:cTn>
                               </p:par>
@@ -15082,6 +16773,25 @@
                                         </p:tgtEl>
                                       </p:cBhvr>
                                     </p:animEffect>
+                                    <p:audio>
+                                      <p:cMediaNode vol="80000">
+                                        <p:cTn id="1007" display="0">
+                                          <p:stCondLst>
+                                            <p:cond delay="0"/>
+                                          </p:stCondLst>
+                                          <p:endCondLst>
+                                            <p:cond evt="onStopAudio" delay="0">
+                                              <p:tgtEl>
+                                                <p:sldTgt/>
+                                              </p:tgtEl>
+                                            </p:cond>
+                                          </p:endCondLst>
+                                        </p:cTn>
+                                        <p:tgtEl>
+                                          <p:sndTgt r:embed="rIdSnd4" name="win.wav"/>
+                                        </p:tgtEl>
+                                      </p:cMediaNode>
+                                    </p:audio>
                                   </p:childTnLst>
                                 </p:cTn>
                               </p:par>
@@ -15778,6 +17488,25 @@
                                         </p:tgtEl>
                                       </p:cBhvr>
                                     </p:animEffect>
+                                    <p:audio>
+                                      <p:cMediaNode vol="80000">
+                                        <p:cTn id="1001" display="0">
+                                          <p:stCondLst>
+                                            <p:cond delay="0"/>
+                                          </p:stCondLst>
+                                          <p:endCondLst>
+                                            <p:cond evt="onStopAudio" delay="0">
+                                              <p:tgtEl>
+                                                <p:sldTgt/>
+                                              </p:tgtEl>
+                                            </p:cond>
+                                          </p:endCondLst>
+                                        </p:cTn>
+                                        <p:tgtEl>
+                                          <p:sndTgt r:embed="rIdSnd1" name="pop.wav"/>
+                                        </p:tgtEl>
+                                      </p:cMediaNode>
+                                    </p:audio>
                                   </p:childTnLst>
                                 </p:cTn>
                               </p:par>
@@ -15831,6 +17560,25 @@
                                         </p:tgtEl>
                                       </p:cBhvr>
                                     </p:animEffect>
+                                    <p:audio>
+                                      <p:cMediaNode vol="80000">
+                                        <p:cTn id="1002" display="0">
+                                          <p:stCondLst>
+                                            <p:cond delay="0"/>
+                                          </p:stCondLst>
+                                          <p:endCondLst>
+                                            <p:cond evt="onStopAudio" delay="0">
+                                              <p:tgtEl>
+                                                <p:sldTgt/>
+                                              </p:tgtEl>
+                                            </p:cond>
+                                          </p:endCondLst>
+                                        </p:cTn>
+                                        <p:tgtEl>
+                                          <p:sndTgt r:embed="rIdSnd2" name="ding.wav"/>
+                                        </p:tgtEl>
+                                      </p:cMediaNode>
+                                    </p:audio>
                                   </p:childTnLst>
                                 </p:cTn>
                               </p:par>
@@ -15884,6 +17632,25 @@
                                         </p:tgtEl>
                                       </p:cBhvr>
                                     </p:animEffect>
+                                    <p:audio>
+                                      <p:cMediaNode vol="80000">
+                                        <p:cTn id="1003" display="0">
+                                          <p:stCondLst>
+                                            <p:cond delay="0"/>
+                                          </p:stCondLst>
+                                          <p:endCondLst>
+                                            <p:cond evt="onStopAudio" delay="0">
+                                              <p:tgtEl>
+                                                <p:sldTgt/>
+                                              </p:tgtEl>
+                                            </p:cond>
+                                          </p:endCondLst>
+                                        </p:cTn>
+                                        <p:tgtEl>
+                                          <p:sndTgt r:embed="rIdSnd3" name="tick.wav"/>
+                                        </p:tgtEl>
+                                      </p:cMediaNode>
+                                    </p:audio>
                                   </p:childTnLst>
                                 </p:cTn>
                               </p:par>
@@ -15937,6 +17704,25 @@
                                         </p:tgtEl>
                                       </p:cBhvr>
                                     </p:animEffect>
+                                    <p:audio>
+                                      <p:cMediaNode vol="80000">
+                                        <p:cTn id="1004" display="0">
+                                          <p:stCondLst>
+                                            <p:cond delay="0"/>
+                                          </p:stCondLst>
+                                          <p:endCondLst>
+                                            <p:cond evt="onStopAudio" delay="0">
+                                              <p:tgtEl>
+                                                <p:sldTgt/>
+                                              </p:tgtEl>
+                                            </p:cond>
+                                          </p:endCondLst>
+                                        </p:cTn>
+                                        <p:tgtEl>
+                                          <p:sndTgt r:embed="rIdSnd1" name="pop.wav"/>
+                                        </p:tgtEl>
+                                      </p:cMediaNode>
+                                    </p:audio>
                                   </p:childTnLst>
                                 </p:cTn>
                               </p:par>
@@ -15990,6 +17776,25 @@
                                         </p:tgtEl>
                                       </p:cBhvr>
                                     </p:animEffect>
+                                    <p:audio>
+                                      <p:cMediaNode vol="80000">
+                                        <p:cTn id="1005" display="0">
+                                          <p:stCondLst>
+                                            <p:cond delay="0"/>
+                                          </p:stCondLst>
+                                          <p:endCondLst>
+                                            <p:cond evt="onStopAudio" delay="0">
+                                              <p:tgtEl>
+                                                <p:sldTgt/>
+                                              </p:tgtEl>
+                                            </p:cond>
+                                          </p:endCondLst>
+                                        </p:cTn>
+                                        <p:tgtEl>
+                                          <p:sndTgt r:embed="rIdSnd2" name="ding.wav"/>
+                                        </p:tgtEl>
+                                      </p:cMediaNode>
+                                    </p:audio>
                                   </p:childTnLst>
                                 </p:cTn>
                               </p:par>
@@ -16043,6 +17848,25 @@
                                         </p:tgtEl>
                                       </p:cBhvr>
                                     </p:animEffect>
+                                    <p:audio>
+                                      <p:cMediaNode vol="80000">
+                                        <p:cTn id="1006" display="0">
+                                          <p:stCondLst>
+                                            <p:cond delay="0"/>
+                                          </p:stCondLst>
+                                          <p:endCondLst>
+                                            <p:cond evt="onStopAudio" delay="0">
+                                              <p:tgtEl>
+                                                <p:sldTgt/>
+                                              </p:tgtEl>
+                                            </p:cond>
+                                          </p:endCondLst>
+                                        </p:cTn>
+                                        <p:tgtEl>
+                                          <p:sndTgt r:embed="rIdSnd3" name="tick.wav"/>
+                                        </p:tgtEl>
+                                      </p:cMediaNode>
+                                    </p:audio>
                                   </p:childTnLst>
                                 </p:cTn>
                               </p:par>
@@ -16096,6 +17920,25 @@
                                         </p:tgtEl>
                                       </p:cBhvr>
                                     </p:animEffect>
+                                    <p:audio>
+                                      <p:cMediaNode vol="80000">
+                                        <p:cTn id="1007" display="0">
+                                          <p:stCondLst>
+                                            <p:cond delay="0"/>
+                                          </p:stCondLst>
+                                          <p:endCondLst>
+                                            <p:cond evt="onStopAudio" delay="0">
+                                              <p:tgtEl>
+                                                <p:sldTgt/>
+                                              </p:tgtEl>
+                                            </p:cond>
+                                          </p:endCondLst>
+                                        </p:cTn>
+                                        <p:tgtEl>
+                                          <p:sndTgt r:embed="rIdSnd4" name="win.wav"/>
+                                        </p:tgtEl>
+                                      </p:cMediaNode>
+                                    </p:audio>
                                   </p:childTnLst>
                                 </p:cTn>
                               </p:par>
@@ -16792,6 +18635,25 @@
                                         </p:tgtEl>
                                       </p:cBhvr>
                                     </p:animEffect>
+                                    <p:audio>
+                                      <p:cMediaNode vol="80000">
+                                        <p:cTn id="1001" display="0">
+                                          <p:stCondLst>
+                                            <p:cond delay="0"/>
+                                          </p:stCondLst>
+                                          <p:endCondLst>
+                                            <p:cond evt="onStopAudio" delay="0">
+                                              <p:tgtEl>
+                                                <p:sldTgt/>
+                                              </p:tgtEl>
+                                            </p:cond>
+                                          </p:endCondLst>
+                                        </p:cTn>
+                                        <p:tgtEl>
+                                          <p:sndTgt r:embed="rIdSnd1" name="pop.wav"/>
+                                        </p:tgtEl>
+                                      </p:cMediaNode>
+                                    </p:audio>
                                   </p:childTnLst>
                                 </p:cTn>
                               </p:par>
@@ -16845,6 +18707,25 @@
                                         </p:tgtEl>
                                       </p:cBhvr>
                                     </p:animEffect>
+                                    <p:audio>
+                                      <p:cMediaNode vol="80000">
+                                        <p:cTn id="1002" display="0">
+                                          <p:stCondLst>
+                                            <p:cond delay="0"/>
+                                          </p:stCondLst>
+                                          <p:endCondLst>
+                                            <p:cond evt="onStopAudio" delay="0">
+                                              <p:tgtEl>
+                                                <p:sldTgt/>
+                                              </p:tgtEl>
+                                            </p:cond>
+                                          </p:endCondLst>
+                                        </p:cTn>
+                                        <p:tgtEl>
+                                          <p:sndTgt r:embed="rIdSnd2" name="ding.wav"/>
+                                        </p:tgtEl>
+                                      </p:cMediaNode>
+                                    </p:audio>
                                   </p:childTnLst>
                                 </p:cTn>
                               </p:par>
@@ -16898,6 +18779,25 @@
                                         </p:tgtEl>
                                       </p:cBhvr>
                                     </p:animEffect>
+                                    <p:audio>
+                                      <p:cMediaNode vol="80000">
+                                        <p:cTn id="1003" display="0">
+                                          <p:stCondLst>
+                                            <p:cond delay="0"/>
+                                          </p:stCondLst>
+                                          <p:endCondLst>
+                                            <p:cond evt="onStopAudio" delay="0">
+                                              <p:tgtEl>
+                                                <p:sldTgt/>
+                                              </p:tgtEl>
+                                            </p:cond>
+                                          </p:endCondLst>
+                                        </p:cTn>
+                                        <p:tgtEl>
+                                          <p:sndTgt r:embed="rIdSnd3" name="tick.wav"/>
+                                        </p:tgtEl>
+                                      </p:cMediaNode>
+                                    </p:audio>
                                   </p:childTnLst>
                                 </p:cTn>
                               </p:par>
@@ -16951,6 +18851,25 @@
                                         </p:tgtEl>
                                       </p:cBhvr>
                                     </p:animEffect>
+                                    <p:audio>
+                                      <p:cMediaNode vol="80000">
+                                        <p:cTn id="1004" display="0">
+                                          <p:stCondLst>
+                                            <p:cond delay="0"/>
+                                          </p:stCondLst>
+                                          <p:endCondLst>
+                                            <p:cond evt="onStopAudio" delay="0">
+                                              <p:tgtEl>
+                                                <p:sldTgt/>
+                                              </p:tgtEl>
+                                            </p:cond>
+                                          </p:endCondLst>
+                                        </p:cTn>
+                                        <p:tgtEl>
+                                          <p:sndTgt r:embed="rIdSnd1" name="pop.wav"/>
+                                        </p:tgtEl>
+                                      </p:cMediaNode>
+                                    </p:audio>
                                   </p:childTnLst>
                                 </p:cTn>
                               </p:par>
@@ -17004,6 +18923,25 @@
                                         </p:tgtEl>
                                       </p:cBhvr>
                                     </p:animEffect>
+                                    <p:audio>
+                                      <p:cMediaNode vol="80000">
+                                        <p:cTn id="1005" display="0">
+                                          <p:stCondLst>
+                                            <p:cond delay="0"/>
+                                          </p:stCondLst>
+                                          <p:endCondLst>
+                                            <p:cond evt="onStopAudio" delay="0">
+                                              <p:tgtEl>
+                                                <p:sldTgt/>
+                                              </p:tgtEl>
+                                            </p:cond>
+                                          </p:endCondLst>
+                                        </p:cTn>
+                                        <p:tgtEl>
+                                          <p:sndTgt r:embed="rIdSnd2" name="ding.wav"/>
+                                        </p:tgtEl>
+                                      </p:cMediaNode>
+                                    </p:audio>
                                   </p:childTnLst>
                                 </p:cTn>
                               </p:par>
@@ -17057,6 +18995,25 @@
                                         </p:tgtEl>
                                       </p:cBhvr>
                                     </p:animEffect>
+                                    <p:audio>
+                                      <p:cMediaNode vol="80000">
+                                        <p:cTn id="1006" display="0">
+                                          <p:stCondLst>
+                                            <p:cond delay="0"/>
+                                          </p:stCondLst>
+                                          <p:endCondLst>
+                                            <p:cond evt="onStopAudio" delay="0">
+                                              <p:tgtEl>
+                                                <p:sldTgt/>
+                                              </p:tgtEl>
+                                            </p:cond>
+                                          </p:endCondLst>
+                                        </p:cTn>
+                                        <p:tgtEl>
+                                          <p:sndTgt r:embed="rIdSnd3" name="tick.wav"/>
+                                        </p:tgtEl>
+                                      </p:cMediaNode>
+                                    </p:audio>
                                   </p:childTnLst>
                                 </p:cTn>
                               </p:par>
@@ -17110,6 +19067,25 @@
                                         </p:tgtEl>
                                       </p:cBhvr>
                                     </p:animEffect>
+                                    <p:audio>
+                                      <p:cMediaNode vol="80000">
+                                        <p:cTn id="1007" display="0">
+                                          <p:stCondLst>
+                                            <p:cond delay="0"/>
+                                          </p:stCondLst>
+                                          <p:endCondLst>
+                                            <p:cond evt="onStopAudio" delay="0">
+                                              <p:tgtEl>
+                                                <p:sldTgt/>
+                                              </p:tgtEl>
+                                            </p:cond>
+                                          </p:endCondLst>
+                                        </p:cTn>
+                                        <p:tgtEl>
+                                          <p:sndTgt r:embed="rIdSnd4" name="win.wav"/>
+                                        </p:tgtEl>
+                                      </p:cMediaNode>
+                                    </p:audio>
                                   </p:childTnLst>
                                 </p:cTn>
                               </p:par>
@@ -17806,6 +19782,25 @@
                                         </p:tgtEl>
                                       </p:cBhvr>
                                     </p:animEffect>
+                                    <p:audio>
+                                      <p:cMediaNode vol="80000">
+                                        <p:cTn id="1001" display="0">
+                                          <p:stCondLst>
+                                            <p:cond delay="0"/>
+                                          </p:stCondLst>
+                                          <p:endCondLst>
+                                            <p:cond evt="onStopAudio" delay="0">
+                                              <p:tgtEl>
+                                                <p:sldTgt/>
+                                              </p:tgtEl>
+                                            </p:cond>
+                                          </p:endCondLst>
+                                        </p:cTn>
+                                        <p:tgtEl>
+                                          <p:sndTgt r:embed="rIdSnd1" name="pop.wav"/>
+                                        </p:tgtEl>
+                                      </p:cMediaNode>
+                                    </p:audio>
                                   </p:childTnLst>
                                 </p:cTn>
                               </p:par>
@@ -17859,6 +19854,25 @@
                                         </p:tgtEl>
                                       </p:cBhvr>
                                     </p:animEffect>
+                                    <p:audio>
+                                      <p:cMediaNode vol="80000">
+                                        <p:cTn id="1002" display="0">
+                                          <p:stCondLst>
+                                            <p:cond delay="0"/>
+                                          </p:stCondLst>
+                                          <p:endCondLst>
+                                            <p:cond evt="onStopAudio" delay="0">
+                                              <p:tgtEl>
+                                                <p:sldTgt/>
+                                              </p:tgtEl>
+                                            </p:cond>
+                                          </p:endCondLst>
+                                        </p:cTn>
+                                        <p:tgtEl>
+                                          <p:sndTgt r:embed="rIdSnd2" name="ding.wav"/>
+                                        </p:tgtEl>
+                                      </p:cMediaNode>
+                                    </p:audio>
                                   </p:childTnLst>
                                 </p:cTn>
                               </p:par>
@@ -17912,6 +19926,25 @@
                                         </p:tgtEl>
                                       </p:cBhvr>
                                     </p:animEffect>
+                                    <p:audio>
+                                      <p:cMediaNode vol="80000">
+                                        <p:cTn id="1003" display="0">
+                                          <p:stCondLst>
+                                            <p:cond delay="0"/>
+                                          </p:stCondLst>
+                                          <p:endCondLst>
+                                            <p:cond evt="onStopAudio" delay="0">
+                                              <p:tgtEl>
+                                                <p:sldTgt/>
+                                              </p:tgtEl>
+                                            </p:cond>
+                                          </p:endCondLst>
+                                        </p:cTn>
+                                        <p:tgtEl>
+                                          <p:sndTgt r:embed="rIdSnd3" name="tick.wav"/>
+                                        </p:tgtEl>
+                                      </p:cMediaNode>
+                                    </p:audio>
                                   </p:childTnLst>
                                 </p:cTn>
                               </p:par>
@@ -17965,6 +19998,25 @@
                                         </p:tgtEl>
                                       </p:cBhvr>
                                     </p:animEffect>
+                                    <p:audio>
+                                      <p:cMediaNode vol="80000">
+                                        <p:cTn id="1004" display="0">
+                                          <p:stCondLst>
+                                            <p:cond delay="0"/>
+                                          </p:stCondLst>
+                                          <p:endCondLst>
+                                            <p:cond evt="onStopAudio" delay="0">
+                                              <p:tgtEl>
+                                                <p:sldTgt/>
+                                              </p:tgtEl>
+                                            </p:cond>
+                                          </p:endCondLst>
+                                        </p:cTn>
+                                        <p:tgtEl>
+                                          <p:sndTgt r:embed="rIdSnd1" name="pop.wav"/>
+                                        </p:tgtEl>
+                                      </p:cMediaNode>
+                                    </p:audio>
                                   </p:childTnLst>
                                 </p:cTn>
                               </p:par>
@@ -18018,6 +20070,25 @@
                                         </p:tgtEl>
                                       </p:cBhvr>
                                     </p:animEffect>
+                                    <p:audio>
+                                      <p:cMediaNode vol="80000">
+                                        <p:cTn id="1005" display="0">
+                                          <p:stCondLst>
+                                            <p:cond delay="0"/>
+                                          </p:stCondLst>
+                                          <p:endCondLst>
+                                            <p:cond evt="onStopAudio" delay="0">
+                                              <p:tgtEl>
+                                                <p:sldTgt/>
+                                              </p:tgtEl>
+                                            </p:cond>
+                                          </p:endCondLst>
+                                        </p:cTn>
+                                        <p:tgtEl>
+                                          <p:sndTgt r:embed="rIdSnd2" name="ding.wav"/>
+                                        </p:tgtEl>
+                                      </p:cMediaNode>
+                                    </p:audio>
                                   </p:childTnLst>
                                 </p:cTn>
                               </p:par>
@@ -18071,6 +20142,25 @@
                                         </p:tgtEl>
                                       </p:cBhvr>
                                     </p:animEffect>
+                                    <p:audio>
+                                      <p:cMediaNode vol="80000">
+                                        <p:cTn id="1006" display="0">
+                                          <p:stCondLst>
+                                            <p:cond delay="0"/>
+                                          </p:stCondLst>
+                                          <p:endCondLst>
+                                            <p:cond evt="onStopAudio" delay="0">
+                                              <p:tgtEl>
+                                                <p:sldTgt/>
+                                              </p:tgtEl>
+                                            </p:cond>
+                                          </p:endCondLst>
+                                        </p:cTn>
+                                        <p:tgtEl>
+                                          <p:sndTgt r:embed="rIdSnd3" name="tick.wav"/>
+                                        </p:tgtEl>
+                                      </p:cMediaNode>
+                                    </p:audio>
                                   </p:childTnLst>
                                 </p:cTn>
                               </p:par>
@@ -18124,6 +20214,25 @@
                                         </p:tgtEl>
                                       </p:cBhvr>
                                     </p:animEffect>
+                                    <p:audio>
+                                      <p:cMediaNode vol="80000">
+                                        <p:cTn id="1007" display="0">
+                                          <p:stCondLst>
+                                            <p:cond delay="0"/>
+                                          </p:stCondLst>
+                                          <p:endCondLst>
+                                            <p:cond evt="onStopAudio" delay="0">
+                                              <p:tgtEl>
+                                                <p:sldTgt/>
+                                              </p:tgtEl>
+                                            </p:cond>
+                                          </p:endCondLst>
+                                        </p:cTn>
+                                        <p:tgtEl>
+                                          <p:sndTgt r:embed="rIdSnd4" name="win.wav"/>
+                                        </p:tgtEl>
+                                      </p:cMediaNode>
+                                    </p:audio>
                                   </p:childTnLst>
                                 </p:cTn>
                               </p:par>
@@ -18820,6 +20929,25 @@
                                         </p:tgtEl>
                                       </p:cBhvr>
                                     </p:animEffect>
+                                    <p:audio>
+                                      <p:cMediaNode vol="80000">
+                                        <p:cTn id="1001" display="0">
+                                          <p:stCondLst>
+                                            <p:cond delay="0"/>
+                                          </p:stCondLst>
+                                          <p:endCondLst>
+                                            <p:cond evt="onStopAudio" delay="0">
+                                              <p:tgtEl>
+                                                <p:sldTgt/>
+                                              </p:tgtEl>
+                                            </p:cond>
+                                          </p:endCondLst>
+                                        </p:cTn>
+                                        <p:tgtEl>
+                                          <p:sndTgt r:embed="rIdSnd1" name="pop.wav"/>
+                                        </p:tgtEl>
+                                      </p:cMediaNode>
+                                    </p:audio>
                                   </p:childTnLst>
                                 </p:cTn>
                               </p:par>
@@ -18873,6 +21001,25 @@
                                         </p:tgtEl>
                                       </p:cBhvr>
                                     </p:animEffect>
+                                    <p:audio>
+                                      <p:cMediaNode vol="80000">
+                                        <p:cTn id="1002" display="0">
+                                          <p:stCondLst>
+                                            <p:cond delay="0"/>
+                                          </p:stCondLst>
+                                          <p:endCondLst>
+                                            <p:cond evt="onStopAudio" delay="0">
+                                              <p:tgtEl>
+                                                <p:sldTgt/>
+                                              </p:tgtEl>
+                                            </p:cond>
+                                          </p:endCondLst>
+                                        </p:cTn>
+                                        <p:tgtEl>
+                                          <p:sndTgt r:embed="rIdSnd2" name="ding.wav"/>
+                                        </p:tgtEl>
+                                      </p:cMediaNode>
+                                    </p:audio>
                                   </p:childTnLst>
                                 </p:cTn>
                               </p:par>
@@ -18926,6 +21073,25 @@
                                         </p:tgtEl>
                                       </p:cBhvr>
                                     </p:animEffect>
+                                    <p:audio>
+                                      <p:cMediaNode vol="80000">
+                                        <p:cTn id="1003" display="0">
+                                          <p:stCondLst>
+                                            <p:cond delay="0"/>
+                                          </p:stCondLst>
+                                          <p:endCondLst>
+                                            <p:cond evt="onStopAudio" delay="0">
+                                              <p:tgtEl>
+                                                <p:sldTgt/>
+                                              </p:tgtEl>
+                                            </p:cond>
+                                          </p:endCondLst>
+                                        </p:cTn>
+                                        <p:tgtEl>
+                                          <p:sndTgt r:embed="rIdSnd3" name="tick.wav"/>
+                                        </p:tgtEl>
+                                      </p:cMediaNode>
+                                    </p:audio>
                                   </p:childTnLst>
                                 </p:cTn>
                               </p:par>
@@ -18979,6 +21145,25 @@
                                         </p:tgtEl>
                                       </p:cBhvr>
                                     </p:animEffect>
+                                    <p:audio>
+                                      <p:cMediaNode vol="80000">
+                                        <p:cTn id="1004" display="0">
+                                          <p:stCondLst>
+                                            <p:cond delay="0"/>
+                                          </p:stCondLst>
+                                          <p:endCondLst>
+                                            <p:cond evt="onStopAudio" delay="0">
+                                              <p:tgtEl>
+                                                <p:sldTgt/>
+                                              </p:tgtEl>
+                                            </p:cond>
+                                          </p:endCondLst>
+                                        </p:cTn>
+                                        <p:tgtEl>
+                                          <p:sndTgt r:embed="rIdSnd1" name="pop.wav"/>
+                                        </p:tgtEl>
+                                      </p:cMediaNode>
+                                    </p:audio>
                                   </p:childTnLst>
                                 </p:cTn>
                               </p:par>
@@ -19032,6 +21217,25 @@
                                         </p:tgtEl>
                                       </p:cBhvr>
                                     </p:animEffect>
+                                    <p:audio>
+                                      <p:cMediaNode vol="80000">
+                                        <p:cTn id="1005" display="0">
+                                          <p:stCondLst>
+                                            <p:cond delay="0"/>
+                                          </p:stCondLst>
+                                          <p:endCondLst>
+                                            <p:cond evt="onStopAudio" delay="0">
+                                              <p:tgtEl>
+                                                <p:sldTgt/>
+                                              </p:tgtEl>
+                                            </p:cond>
+                                          </p:endCondLst>
+                                        </p:cTn>
+                                        <p:tgtEl>
+                                          <p:sndTgt r:embed="rIdSnd2" name="ding.wav"/>
+                                        </p:tgtEl>
+                                      </p:cMediaNode>
+                                    </p:audio>
                                   </p:childTnLst>
                                 </p:cTn>
                               </p:par>
@@ -19085,6 +21289,25 @@
                                         </p:tgtEl>
                                       </p:cBhvr>
                                     </p:animEffect>
+                                    <p:audio>
+                                      <p:cMediaNode vol="80000">
+                                        <p:cTn id="1006" display="0">
+                                          <p:stCondLst>
+                                            <p:cond delay="0"/>
+                                          </p:stCondLst>
+                                          <p:endCondLst>
+                                            <p:cond evt="onStopAudio" delay="0">
+                                              <p:tgtEl>
+                                                <p:sldTgt/>
+                                              </p:tgtEl>
+                                            </p:cond>
+                                          </p:endCondLst>
+                                        </p:cTn>
+                                        <p:tgtEl>
+                                          <p:sndTgt r:embed="rIdSnd3" name="tick.wav"/>
+                                        </p:tgtEl>
+                                      </p:cMediaNode>
+                                    </p:audio>
                                   </p:childTnLst>
                                 </p:cTn>
                               </p:par>
@@ -19138,6 +21361,25 @@
                                         </p:tgtEl>
                                       </p:cBhvr>
                                     </p:animEffect>
+                                    <p:audio>
+                                      <p:cMediaNode vol="80000">
+                                        <p:cTn id="1007" display="0">
+                                          <p:stCondLst>
+                                            <p:cond delay="0"/>
+                                          </p:stCondLst>
+                                          <p:endCondLst>
+                                            <p:cond evt="onStopAudio" delay="0">
+                                              <p:tgtEl>
+                                                <p:sldTgt/>
+                                              </p:tgtEl>
+                                            </p:cond>
+                                          </p:endCondLst>
+                                        </p:cTn>
+                                        <p:tgtEl>
+                                          <p:sndTgt r:embed="rIdSnd4" name="win.wav"/>
+                                        </p:tgtEl>
+                                      </p:cMediaNode>
+                                    </p:audio>
                                   </p:childTnLst>
                                 </p:cTn>
                               </p:par>
@@ -19834,6 +22076,25 @@
                                         </p:tgtEl>
                                       </p:cBhvr>
                                     </p:animEffect>
+                                    <p:audio>
+                                      <p:cMediaNode vol="80000">
+                                        <p:cTn id="1001" display="0">
+                                          <p:stCondLst>
+                                            <p:cond delay="0"/>
+                                          </p:stCondLst>
+                                          <p:endCondLst>
+                                            <p:cond evt="onStopAudio" delay="0">
+                                              <p:tgtEl>
+                                                <p:sldTgt/>
+                                              </p:tgtEl>
+                                            </p:cond>
+                                          </p:endCondLst>
+                                        </p:cTn>
+                                        <p:tgtEl>
+                                          <p:sndTgt r:embed="rIdSnd1" name="pop.wav"/>
+                                        </p:tgtEl>
+                                      </p:cMediaNode>
+                                    </p:audio>
                                   </p:childTnLst>
                                 </p:cTn>
                               </p:par>
@@ -19887,6 +22148,25 @@
                                         </p:tgtEl>
                                       </p:cBhvr>
                                     </p:animEffect>
+                                    <p:audio>
+                                      <p:cMediaNode vol="80000">
+                                        <p:cTn id="1002" display="0">
+                                          <p:stCondLst>
+                                            <p:cond delay="0"/>
+                                          </p:stCondLst>
+                                          <p:endCondLst>
+                                            <p:cond evt="onStopAudio" delay="0">
+                                              <p:tgtEl>
+                                                <p:sldTgt/>
+                                              </p:tgtEl>
+                                            </p:cond>
+                                          </p:endCondLst>
+                                        </p:cTn>
+                                        <p:tgtEl>
+                                          <p:sndTgt r:embed="rIdSnd2" name="ding.wav"/>
+                                        </p:tgtEl>
+                                      </p:cMediaNode>
+                                    </p:audio>
                                   </p:childTnLst>
                                 </p:cTn>
                               </p:par>
@@ -19940,6 +22220,25 @@
                                         </p:tgtEl>
                                       </p:cBhvr>
                                     </p:animEffect>
+                                    <p:audio>
+                                      <p:cMediaNode vol="80000">
+                                        <p:cTn id="1003" display="0">
+                                          <p:stCondLst>
+                                            <p:cond delay="0"/>
+                                          </p:stCondLst>
+                                          <p:endCondLst>
+                                            <p:cond evt="onStopAudio" delay="0">
+                                              <p:tgtEl>
+                                                <p:sldTgt/>
+                                              </p:tgtEl>
+                                            </p:cond>
+                                          </p:endCondLst>
+                                        </p:cTn>
+                                        <p:tgtEl>
+                                          <p:sndTgt r:embed="rIdSnd3" name="tick.wav"/>
+                                        </p:tgtEl>
+                                      </p:cMediaNode>
+                                    </p:audio>
                                   </p:childTnLst>
                                 </p:cTn>
                               </p:par>
@@ -19993,6 +22292,25 @@
                                         </p:tgtEl>
                                       </p:cBhvr>
                                     </p:animEffect>
+                                    <p:audio>
+                                      <p:cMediaNode vol="80000">
+                                        <p:cTn id="1004" display="0">
+                                          <p:stCondLst>
+                                            <p:cond delay="0"/>
+                                          </p:stCondLst>
+                                          <p:endCondLst>
+                                            <p:cond evt="onStopAudio" delay="0">
+                                              <p:tgtEl>
+                                                <p:sldTgt/>
+                                              </p:tgtEl>
+                                            </p:cond>
+                                          </p:endCondLst>
+                                        </p:cTn>
+                                        <p:tgtEl>
+                                          <p:sndTgt r:embed="rIdSnd1" name="pop.wav"/>
+                                        </p:tgtEl>
+                                      </p:cMediaNode>
+                                    </p:audio>
                                   </p:childTnLst>
                                 </p:cTn>
                               </p:par>
@@ -20046,6 +22364,25 @@
                                         </p:tgtEl>
                                       </p:cBhvr>
                                     </p:animEffect>
+                                    <p:audio>
+                                      <p:cMediaNode vol="80000">
+                                        <p:cTn id="1005" display="0">
+                                          <p:stCondLst>
+                                            <p:cond delay="0"/>
+                                          </p:stCondLst>
+                                          <p:endCondLst>
+                                            <p:cond evt="onStopAudio" delay="0">
+                                              <p:tgtEl>
+                                                <p:sldTgt/>
+                                              </p:tgtEl>
+                                            </p:cond>
+                                          </p:endCondLst>
+                                        </p:cTn>
+                                        <p:tgtEl>
+                                          <p:sndTgt r:embed="rIdSnd2" name="ding.wav"/>
+                                        </p:tgtEl>
+                                      </p:cMediaNode>
+                                    </p:audio>
                                   </p:childTnLst>
                                 </p:cTn>
                               </p:par>
@@ -20099,6 +22436,25 @@
                                         </p:tgtEl>
                                       </p:cBhvr>
                                     </p:animEffect>
+                                    <p:audio>
+                                      <p:cMediaNode vol="80000">
+                                        <p:cTn id="1006" display="0">
+                                          <p:stCondLst>
+                                            <p:cond delay="0"/>
+                                          </p:stCondLst>
+                                          <p:endCondLst>
+                                            <p:cond evt="onStopAudio" delay="0">
+                                              <p:tgtEl>
+                                                <p:sldTgt/>
+                                              </p:tgtEl>
+                                            </p:cond>
+                                          </p:endCondLst>
+                                        </p:cTn>
+                                        <p:tgtEl>
+                                          <p:sndTgt r:embed="rIdSnd3" name="tick.wav"/>
+                                        </p:tgtEl>
+                                      </p:cMediaNode>
+                                    </p:audio>
                                   </p:childTnLst>
                                 </p:cTn>
                               </p:par>
@@ -20152,6 +22508,25 @@
                                         </p:tgtEl>
                                       </p:cBhvr>
                                     </p:animEffect>
+                                    <p:audio>
+                                      <p:cMediaNode vol="80000">
+                                        <p:cTn id="1007" display="0">
+                                          <p:stCondLst>
+                                            <p:cond delay="0"/>
+                                          </p:stCondLst>
+                                          <p:endCondLst>
+                                            <p:cond evt="onStopAudio" delay="0">
+                                              <p:tgtEl>
+                                                <p:sldTgt/>
+                                              </p:tgtEl>
+                                            </p:cond>
+                                          </p:endCondLst>
+                                        </p:cTn>
+                                        <p:tgtEl>
+                                          <p:sndTgt r:embed="rIdSnd4" name="win.wav"/>
+                                        </p:tgtEl>
+                                      </p:cMediaNode>
+                                    </p:audio>
                                   </p:childTnLst>
                                 </p:cTn>
                               </p:par>
@@ -20848,6 +23223,25 @@
                                         </p:tgtEl>
                                       </p:cBhvr>
                                     </p:animEffect>
+                                    <p:audio>
+                                      <p:cMediaNode vol="80000">
+                                        <p:cTn id="1001" display="0">
+                                          <p:stCondLst>
+                                            <p:cond delay="0"/>
+                                          </p:stCondLst>
+                                          <p:endCondLst>
+                                            <p:cond evt="onStopAudio" delay="0">
+                                              <p:tgtEl>
+                                                <p:sldTgt/>
+                                              </p:tgtEl>
+                                            </p:cond>
+                                          </p:endCondLst>
+                                        </p:cTn>
+                                        <p:tgtEl>
+                                          <p:sndTgt r:embed="rIdSnd1" name="pop.wav"/>
+                                        </p:tgtEl>
+                                      </p:cMediaNode>
+                                    </p:audio>
                                   </p:childTnLst>
                                 </p:cTn>
                               </p:par>
@@ -20901,6 +23295,25 @@
                                         </p:tgtEl>
                                       </p:cBhvr>
                                     </p:animEffect>
+                                    <p:audio>
+                                      <p:cMediaNode vol="80000">
+                                        <p:cTn id="1002" display="0">
+                                          <p:stCondLst>
+                                            <p:cond delay="0"/>
+                                          </p:stCondLst>
+                                          <p:endCondLst>
+                                            <p:cond evt="onStopAudio" delay="0">
+                                              <p:tgtEl>
+                                                <p:sldTgt/>
+                                              </p:tgtEl>
+                                            </p:cond>
+                                          </p:endCondLst>
+                                        </p:cTn>
+                                        <p:tgtEl>
+                                          <p:sndTgt r:embed="rIdSnd2" name="ding.wav"/>
+                                        </p:tgtEl>
+                                      </p:cMediaNode>
+                                    </p:audio>
                                   </p:childTnLst>
                                 </p:cTn>
                               </p:par>
@@ -20954,6 +23367,25 @@
                                         </p:tgtEl>
                                       </p:cBhvr>
                                     </p:animEffect>
+                                    <p:audio>
+                                      <p:cMediaNode vol="80000">
+                                        <p:cTn id="1003" display="0">
+                                          <p:stCondLst>
+                                            <p:cond delay="0"/>
+                                          </p:stCondLst>
+                                          <p:endCondLst>
+                                            <p:cond evt="onStopAudio" delay="0">
+                                              <p:tgtEl>
+                                                <p:sldTgt/>
+                                              </p:tgtEl>
+                                            </p:cond>
+                                          </p:endCondLst>
+                                        </p:cTn>
+                                        <p:tgtEl>
+                                          <p:sndTgt r:embed="rIdSnd3" name="tick.wav"/>
+                                        </p:tgtEl>
+                                      </p:cMediaNode>
+                                    </p:audio>
                                   </p:childTnLst>
                                 </p:cTn>
                               </p:par>
@@ -21007,6 +23439,25 @@
                                         </p:tgtEl>
                                       </p:cBhvr>
                                     </p:animEffect>
+                                    <p:audio>
+                                      <p:cMediaNode vol="80000">
+                                        <p:cTn id="1004" display="0">
+                                          <p:stCondLst>
+                                            <p:cond delay="0"/>
+                                          </p:stCondLst>
+                                          <p:endCondLst>
+                                            <p:cond evt="onStopAudio" delay="0">
+                                              <p:tgtEl>
+                                                <p:sldTgt/>
+                                              </p:tgtEl>
+                                            </p:cond>
+                                          </p:endCondLst>
+                                        </p:cTn>
+                                        <p:tgtEl>
+                                          <p:sndTgt r:embed="rIdSnd1" name="pop.wav"/>
+                                        </p:tgtEl>
+                                      </p:cMediaNode>
+                                    </p:audio>
                                   </p:childTnLst>
                                 </p:cTn>
                               </p:par>
@@ -21060,6 +23511,25 @@
                                         </p:tgtEl>
                                       </p:cBhvr>
                                     </p:animEffect>
+                                    <p:audio>
+                                      <p:cMediaNode vol="80000">
+                                        <p:cTn id="1005" display="0">
+                                          <p:stCondLst>
+                                            <p:cond delay="0"/>
+                                          </p:stCondLst>
+                                          <p:endCondLst>
+                                            <p:cond evt="onStopAudio" delay="0">
+                                              <p:tgtEl>
+                                                <p:sldTgt/>
+                                              </p:tgtEl>
+                                            </p:cond>
+                                          </p:endCondLst>
+                                        </p:cTn>
+                                        <p:tgtEl>
+                                          <p:sndTgt r:embed="rIdSnd2" name="ding.wav"/>
+                                        </p:tgtEl>
+                                      </p:cMediaNode>
+                                    </p:audio>
                                   </p:childTnLst>
                                 </p:cTn>
                               </p:par>
@@ -21113,6 +23583,25 @@
                                         </p:tgtEl>
                                       </p:cBhvr>
                                     </p:animEffect>
+                                    <p:audio>
+                                      <p:cMediaNode vol="80000">
+                                        <p:cTn id="1006" display="0">
+                                          <p:stCondLst>
+                                            <p:cond delay="0"/>
+                                          </p:stCondLst>
+                                          <p:endCondLst>
+                                            <p:cond evt="onStopAudio" delay="0">
+                                              <p:tgtEl>
+                                                <p:sldTgt/>
+                                              </p:tgtEl>
+                                            </p:cond>
+                                          </p:endCondLst>
+                                        </p:cTn>
+                                        <p:tgtEl>
+                                          <p:sndTgt r:embed="rIdSnd3" name="tick.wav"/>
+                                        </p:tgtEl>
+                                      </p:cMediaNode>
+                                    </p:audio>
                                   </p:childTnLst>
                                 </p:cTn>
                               </p:par>
@@ -21166,6 +23655,25 @@
                                         </p:tgtEl>
                                       </p:cBhvr>
                                     </p:animEffect>
+                                    <p:audio>
+                                      <p:cMediaNode vol="80000">
+                                        <p:cTn id="1007" display="0">
+                                          <p:stCondLst>
+                                            <p:cond delay="0"/>
+                                          </p:stCondLst>
+                                          <p:endCondLst>
+                                            <p:cond evt="onStopAudio" delay="0">
+                                              <p:tgtEl>
+                                                <p:sldTgt/>
+                                              </p:tgtEl>
+                                            </p:cond>
+                                          </p:endCondLst>
+                                        </p:cTn>
+                                        <p:tgtEl>
+                                          <p:sndTgt r:embed="rIdSnd4" name="win.wav"/>
+                                        </p:tgtEl>
+                                      </p:cMediaNode>
+                                    </p:audio>
                                   </p:childTnLst>
                                 </p:cTn>
                               </p:par>
@@ -21862,6 +24370,25 @@
                                         </p:tgtEl>
                                       </p:cBhvr>
                                     </p:animEffect>
+                                    <p:audio>
+                                      <p:cMediaNode vol="80000">
+                                        <p:cTn id="1001" display="0">
+                                          <p:stCondLst>
+                                            <p:cond delay="0"/>
+                                          </p:stCondLst>
+                                          <p:endCondLst>
+                                            <p:cond evt="onStopAudio" delay="0">
+                                              <p:tgtEl>
+                                                <p:sldTgt/>
+                                              </p:tgtEl>
+                                            </p:cond>
+                                          </p:endCondLst>
+                                        </p:cTn>
+                                        <p:tgtEl>
+                                          <p:sndTgt r:embed="rIdSnd1" name="pop.wav"/>
+                                        </p:tgtEl>
+                                      </p:cMediaNode>
+                                    </p:audio>
                                   </p:childTnLst>
                                 </p:cTn>
                               </p:par>
@@ -21915,6 +24442,25 @@
                                         </p:tgtEl>
                                       </p:cBhvr>
                                     </p:animEffect>
+                                    <p:audio>
+                                      <p:cMediaNode vol="80000">
+                                        <p:cTn id="1002" display="0">
+                                          <p:stCondLst>
+                                            <p:cond delay="0"/>
+                                          </p:stCondLst>
+                                          <p:endCondLst>
+                                            <p:cond evt="onStopAudio" delay="0">
+                                              <p:tgtEl>
+                                                <p:sldTgt/>
+                                              </p:tgtEl>
+                                            </p:cond>
+                                          </p:endCondLst>
+                                        </p:cTn>
+                                        <p:tgtEl>
+                                          <p:sndTgt r:embed="rIdSnd2" name="ding.wav"/>
+                                        </p:tgtEl>
+                                      </p:cMediaNode>
+                                    </p:audio>
                                   </p:childTnLst>
                                 </p:cTn>
                               </p:par>
@@ -21968,6 +24514,25 @@
                                         </p:tgtEl>
                                       </p:cBhvr>
                                     </p:animEffect>
+                                    <p:audio>
+                                      <p:cMediaNode vol="80000">
+                                        <p:cTn id="1003" display="0">
+                                          <p:stCondLst>
+                                            <p:cond delay="0"/>
+                                          </p:stCondLst>
+                                          <p:endCondLst>
+                                            <p:cond evt="onStopAudio" delay="0">
+                                              <p:tgtEl>
+                                                <p:sldTgt/>
+                                              </p:tgtEl>
+                                            </p:cond>
+                                          </p:endCondLst>
+                                        </p:cTn>
+                                        <p:tgtEl>
+                                          <p:sndTgt r:embed="rIdSnd3" name="tick.wav"/>
+                                        </p:tgtEl>
+                                      </p:cMediaNode>
+                                    </p:audio>
                                   </p:childTnLst>
                                 </p:cTn>
                               </p:par>
@@ -22021,6 +24586,25 @@
                                         </p:tgtEl>
                                       </p:cBhvr>
                                     </p:animEffect>
+                                    <p:audio>
+                                      <p:cMediaNode vol="80000">
+                                        <p:cTn id="1004" display="0">
+                                          <p:stCondLst>
+                                            <p:cond delay="0"/>
+                                          </p:stCondLst>
+                                          <p:endCondLst>
+                                            <p:cond evt="onStopAudio" delay="0">
+                                              <p:tgtEl>
+                                                <p:sldTgt/>
+                                              </p:tgtEl>
+                                            </p:cond>
+                                          </p:endCondLst>
+                                        </p:cTn>
+                                        <p:tgtEl>
+                                          <p:sndTgt r:embed="rIdSnd1" name="pop.wav"/>
+                                        </p:tgtEl>
+                                      </p:cMediaNode>
+                                    </p:audio>
                                   </p:childTnLst>
                                 </p:cTn>
                               </p:par>
@@ -22074,6 +24658,25 @@
                                         </p:tgtEl>
                                       </p:cBhvr>
                                     </p:animEffect>
+                                    <p:audio>
+                                      <p:cMediaNode vol="80000">
+                                        <p:cTn id="1005" display="0">
+                                          <p:stCondLst>
+                                            <p:cond delay="0"/>
+                                          </p:stCondLst>
+                                          <p:endCondLst>
+                                            <p:cond evt="onStopAudio" delay="0">
+                                              <p:tgtEl>
+                                                <p:sldTgt/>
+                                              </p:tgtEl>
+                                            </p:cond>
+                                          </p:endCondLst>
+                                        </p:cTn>
+                                        <p:tgtEl>
+                                          <p:sndTgt r:embed="rIdSnd2" name="ding.wav"/>
+                                        </p:tgtEl>
+                                      </p:cMediaNode>
+                                    </p:audio>
                                   </p:childTnLst>
                                 </p:cTn>
                               </p:par>
@@ -22127,6 +24730,25 @@
                                         </p:tgtEl>
                                       </p:cBhvr>
                                     </p:animEffect>
+                                    <p:audio>
+                                      <p:cMediaNode vol="80000">
+                                        <p:cTn id="1006" display="0">
+                                          <p:stCondLst>
+                                            <p:cond delay="0"/>
+                                          </p:stCondLst>
+                                          <p:endCondLst>
+                                            <p:cond evt="onStopAudio" delay="0">
+                                              <p:tgtEl>
+                                                <p:sldTgt/>
+                                              </p:tgtEl>
+                                            </p:cond>
+                                          </p:endCondLst>
+                                        </p:cTn>
+                                        <p:tgtEl>
+                                          <p:sndTgt r:embed="rIdSnd3" name="tick.wav"/>
+                                        </p:tgtEl>
+                                      </p:cMediaNode>
+                                    </p:audio>
                                   </p:childTnLst>
                                 </p:cTn>
                               </p:par>
@@ -22180,6 +24802,25 @@
                                         </p:tgtEl>
                                       </p:cBhvr>
                                     </p:animEffect>
+                                    <p:audio>
+                                      <p:cMediaNode vol="80000">
+                                        <p:cTn id="1007" display="0">
+                                          <p:stCondLst>
+                                            <p:cond delay="0"/>
+                                          </p:stCondLst>
+                                          <p:endCondLst>
+                                            <p:cond evt="onStopAudio" delay="0">
+                                              <p:tgtEl>
+                                                <p:sldTgt/>
+                                              </p:tgtEl>
+                                            </p:cond>
+                                          </p:endCondLst>
+                                        </p:cTn>
+                                        <p:tgtEl>
+                                          <p:sndTgt r:embed="rIdSnd4" name="win.wav"/>
+                                        </p:tgtEl>
+                                      </p:cMediaNode>
+                                    </p:audio>
                                   </p:childTnLst>
                                 </p:cTn>
                               </p:par>
@@ -22876,6 +25517,25 @@
                                         </p:tgtEl>
                                       </p:cBhvr>
                                     </p:animEffect>
+                                    <p:audio>
+                                      <p:cMediaNode vol="80000">
+                                        <p:cTn id="1001" display="0">
+                                          <p:stCondLst>
+                                            <p:cond delay="0"/>
+                                          </p:stCondLst>
+                                          <p:endCondLst>
+                                            <p:cond evt="onStopAudio" delay="0">
+                                              <p:tgtEl>
+                                                <p:sldTgt/>
+                                              </p:tgtEl>
+                                            </p:cond>
+                                          </p:endCondLst>
+                                        </p:cTn>
+                                        <p:tgtEl>
+                                          <p:sndTgt r:embed="rIdSnd1" name="pop.wav"/>
+                                        </p:tgtEl>
+                                      </p:cMediaNode>
+                                    </p:audio>
                                   </p:childTnLst>
                                 </p:cTn>
                               </p:par>
@@ -22929,6 +25589,25 @@
                                         </p:tgtEl>
                                       </p:cBhvr>
                                     </p:animEffect>
+                                    <p:audio>
+                                      <p:cMediaNode vol="80000">
+                                        <p:cTn id="1002" display="0">
+                                          <p:stCondLst>
+                                            <p:cond delay="0"/>
+                                          </p:stCondLst>
+                                          <p:endCondLst>
+                                            <p:cond evt="onStopAudio" delay="0">
+                                              <p:tgtEl>
+                                                <p:sldTgt/>
+                                              </p:tgtEl>
+                                            </p:cond>
+                                          </p:endCondLst>
+                                        </p:cTn>
+                                        <p:tgtEl>
+                                          <p:sndTgt r:embed="rIdSnd2" name="ding.wav"/>
+                                        </p:tgtEl>
+                                      </p:cMediaNode>
+                                    </p:audio>
                                   </p:childTnLst>
                                 </p:cTn>
                               </p:par>
@@ -22982,6 +25661,25 @@
                                         </p:tgtEl>
                                       </p:cBhvr>
                                     </p:animEffect>
+                                    <p:audio>
+                                      <p:cMediaNode vol="80000">
+                                        <p:cTn id="1003" display="0">
+                                          <p:stCondLst>
+                                            <p:cond delay="0"/>
+                                          </p:stCondLst>
+                                          <p:endCondLst>
+                                            <p:cond evt="onStopAudio" delay="0">
+                                              <p:tgtEl>
+                                                <p:sldTgt/>
+                                              </p:tgtEl>
+                                            </p:cond>
+                                          </p:endCondLst>
+                                        </p:cTn>
+                                        <p:tgtEl>
+                                          <p:sndTgt r:embed="rIdSnd3" name="tick.wav"/>
+                                        </p:tgtEl>
+                                      </p:cMediaNode>
+                                    </p:audio>
                                   </p:childTnLst>
                                 </p:cTn>
                               </p:par>
@@ -23035,6 +25733,25 @@
                                         </p:tgtEl>
                                       </p:cBhvr>
                                     </p:animEffect>
+                                    <p:audio>
+                                      <p:cMediaNode vol="80000">
+                                        <p:cTn id="1004" display="0">
+                                          <p:stCondLst>
+                                            <p:cond delay="0"/>
+                                          </p:stCondLst>
+                                          <p:endCondLst>
+                                            <p:cond evt="onStopAudio" delay="0">
+                                              <p:tgtEl>
+                                                <p:sldTgt/>
+                                              </p:tgtEl>
+                                            </p:cond>
+                                          </p:endCondLst>
+                                        </p:cTn>
+                                        <p:tgtEl>
+                                          <p:sndTgt r:embed="rIdSnd1" name="pop.wav"/>
+                                        </p:tgtEl>
+                                      </p:cMediaNode>
+                                    </p:audio>
                                   </p:childTnLst>
                                 </p:cTn>
                               </p:par>
@@ -23088,6 +25805,25 @@
                                         </p:tgtEl>
                                       </p:cBhvr>
                                     </p:animEffect>
+                                    <p:audio>
+                                      <p:cMediaNode vol="80000">
+                                        <p:cTn id="1005" display="0">
+                                          <p:stCondLst>
+                                            <p:cond delay="0"/>
+                                          </p:stCondLst>
+                                          <p:endCondLst>
+                                            <p:cond evt="onStopAudio" delay="0">
+                                              <p:tgtEl>
+                                                <p:sldTgt/>
+                                              </p:tgtEl>
+                                            </p:cond>
+                                          </p:endCondLst>
+                                        </p:cTn>
+                                        <p:tgtEl>
+                                          <p:sndTgt r:embed="rIdSnd2" name="ding.wav"/>
+                                        </p:tgtEl>
+                                      </p:cMediaNode>
+                                    </p:audio>
                                   </p:childTnLst>
                                 </p:cTn>
                               </p:par>
@@ -23141,6 +25877,25 @@
                                         </p:tgtEl>
                                       </p:cBhvr>
                                     </p:animEffect>
+                                    <p:audio>
+                                      <p:cMediaNode vol="80000">
+                                        <p:cTn id="1006" display="0">
+                                          <p:stCondLst>
+                                            <p:cond delay="0"/>
+                                          </p:stCondLst>
+                                          <p:endCondLst>
+                                            <p:cond evt="onStopAudio" delay="0">
+                                              <p:tgtEl>
+                                                <p:sldTgt/>
+                                              </p:tgtEl>
+                                            </p:cond>
+                                          </p:endCondLst>
+                                        </p:cTn>
+                                        <p:tgtEl>
+                                          <p:sndTgt r:embed="rIdSnd3" name="tick.wav"/>
+                                        </p:tgtEl>
+                                      </p:cMediaNode>
+                                    </p:audio>
                                   </p:childTnLst>
                                 </p:cTn>
                               </p:par>
@@ -23194,6 +25949,25 @@
                                         </p:tgtEl>
                                       </p:cBhvr>
                                     </p:animEffect>
+                                    <p:audio>
+                                      <p:cMediaNode vol="80000">
+                                        <p:cTn id="1007" display="0">
+                                          <p:stCondLst>
+                                            <p:cond delay="0"/>
+                                          </p:stCondLst>
+                                          <p:endCondLst>
+                                            <p:cond evt="onStopAudio" delay="0">
+                                              <p:tgtEl>
+                                                <p:sldTgt/>
+                                              </p:tgtEl>
+                                            </p:cond>
+                                          </p:endCondLst>
+                                        </p:cTn>
+                                        <p:tgtEl>
+                                          <p:sndTgt r:embed="rIdSnd4" name="win.wav"/>
+                                        </p:tgtEl>
+                                      </p:cMediaNode>
+                                    </p:audio>
                                   </p:childTnLst>
                                 </p:cTn>
                               </p:par>
@@ -23890,6 +26664,25 @@
                                         </p:tgtEl>
                                       </p:cBhvr>
                                     </p:animEffect>
+                                    <p:audio>
+                                      <p:cMediaNode vol="80000">
+                                        <p:cTn id="1001" display="0">
+                                          <p:stCondLst>
+                                            <p:cond delay="0"/>
+                                          </p:stCondLst>
+                                          <p:endCondLst>
+                                            <p:cond evt="onStopAudio" delay="0">
+                                              <p:tgtEl>
+                                                <p:sldTgt/>
+                                              </p:tgtEl>
+                                            </p:cond>
+                                          </p:endCondLst>
+                                        </p:cTn>
+                                        <p:tgtEl>
+                                          <p:sndTgt r:embed="rIdSnd1" name="pop.wav"/>
+                                        </p:tgtEl>
+                                      </p:cMediaNode>
+                                    </p:audio>
                                   </p:childTnLst>
                                 </p:cTn>
                               </p:par>
@@ -23943,6 +26736,25 @@
                                         </p:tgtEl>
                                       </p:cBhvr>
                                     </p:animEffect>
+                                    <p:audio>
+                                      <p:cMediaNode vol="80000">
+                                        <p:cTn id="1002" display="0">
+                                          <p:stCondLst>
+                                            <p:cond delay="0"/>
+                                          </p:stCondLst>
+                                          <p:endCondLst>
+                                            <p:cond evt="onStopAudio" delay="0">
+                                              <p:tgtEl>
+                                                <p:sldTgt/>
+                                              </p:tgtEl>
+                                            </p:cond>
+                                          </p:endCondLst>
+                                        </p:cTn>
+                                        <p:tgtEl>
+                                          <p:sndTgt r:embed="rIdSnd2" name="ding.wav"/>
+                                        </p:tgtEl>
+                                      </p:cMediaNode>
+                                    </p:audio>
                                   </p:childTnLst>
                                 </p:cTn>
                               </p:par>
@@ -23996,6 +26808,25 @@
                                         </p:tgtEl>
                                       </p:cBhvr>
                                     </p:animEffect>
+                                    <p:audio>
+                                      <p:cMediaNode vol="80000">
+                                        <p:cTn id="1003" display="0">
+                                          <p:stCondLst>
+                                            <p:cond delay="0"/>
+                                          </p:stCondLst>
+                                          <p:endCondLst>
+                                            <p:cond evt="onStopAudio" delay="0">
+                                              <p:tgtEl>
+                                                <p:sldTgt/>
+                                              </p:tgtEl>
+                                            </p:cond>
+                                          </p:endCondLst>
+                                        </p:cTn>
+                                        <p:tgtEl>
+                                          <p:sndTgt r:embed="rIdSnd3" name="tick.wav"/>
+                                        </p:tgtEl>
+                                      </p:cMediaNode>
+                                    </p:audio>
                                   </p:childTnLst>
                                 </p:cTn>
                               </p:par>
@@ -24049,6 +26880,25 @@
                                         </p:tgtEl>
                                       </p:cBhvr>
                                     </p:animEffect>
+                                    <p:audio>
+                                      <p:cMediaNode vol="80000">
+                                        <p:cTn id="1004" display="0">
+                                          <p:stCondLst>
+                                            <p:cond delay="0"/>
+                                          </p:stCondLst>
+                                          <p:endCondLst>
+                                            <p:cond evt="onStopAudio" delay="0">
+                                              <p:tgtEl>
+                                                <p:sldTgt/>
+                                              </p:tgtEl>
+                                            </p:cond>
+                                          </p:endCondLst>
+                                        </p:cTn>
+                                        <p:tgtEl>
+                                          <p:sndTgt r:embed="rIdSnd1" name="pop.wav"/>
+                                        </p:tgtEl>
+                                      </p:cMediaNode>
+                                    </p:audio>
                                   </p:childTnLst>
                                 </p:cTn>
                               </p:par>
@@ -24102,6 +26952,25 @@
                                         </p:tgtEl>
                                       </p:cBhvr>
                                     </p:animEffect>
+                                    <p:audio>
+                                      <p:cMediaNode vol="80000">
+                                        <p:cTn id="1005" display="0">
+                                          <p:stCondLst>
+                                            <p:cond delay="0"/>
+                                          </p:stCondLst>
+                                          <p:endCondLst>
+                                            <p:cond evt="onStopAudio" delay="0">
+                                              <p:tgtEl>
+                                                <p:sldTgt/>
+                                              </p:tgtEl>
+                                            </p:cond>
+                                          </p:endCondLst>
+                                        </p:cTn>
+                                        <p:tgtEl>
+                                          <p:sndTgt r:embed="rIdSnd2" name="ding.wav"/>
+                                        </p:tgtEl>
+                                      </p:cMediaNode>
+                                    </p:audio>
                                   </p:childTnLst>
                                 </p:cTn>
                               </p:par>
@@ -24155,6 +27024,25 @@
                                         </p:tgtEl>
                                       </p:cBhvr>
                                     </p:animEffect>
+                                    <p:audio>
+                                      <p:cMediaNode vol="80000">
+                                        <p:cTn id="1006" display="0">
+                                          <p:stCondLst>
+                                            <p:cond delay="0"/>
+                                          </p:stCondLst>
+                                          <p:endCondLst>
+                                            <p:cond evt="onStopAudio" delay="0">
+                                              <p:tgtEl>
+                                                <p:sldTgt/>
+                                              </p:tgtEl>
+                                            </p:cond>
+                                          </p:endCondLst>
+                                        </p:cTn>
+                                        <p:tgtEl>
+                                          <p:sndTgt r:embed="rIdSnd3" name="tick.wav"/>
+                                        </p:tgtEl>
+                                      </p:cMediaNode>
+                                    </p:audio>
                                   </p:childTnLst>
                                 </p:cTn>
                               </p:par>
@@ -24208,6 +27096,25 @@
                                         </p:tgtEl>
                                       </p:cBhvr>
                                     </p:animEffect>
+                                    <p:audio>
+                                      <p:cMediaNode vol="80000">
+                                        <p:cTn id="1007" display="0">
+                                          <p:stCondLst>
+                                            <p:cond delay="0"/>
+                                          </p:stCondLst>
+                                          <p:endCondLst>
+                                            <p:cond evt="onStopAudio" delay="0">
+                                              <p:tgtEl>
+                                                <p:sldTgt/>
+                                              </p:tgtEl>
+                                            </p:cond>
+                                          </p:endCondLst>
+                                        </p:cTn>
+                                        <p:tgtEl>
+                                          <p:sndTgt r:embed="rIdSnd4" name="win.wav"/>
+                                        </p:tgtEl>
+                                      </p:cMediaNode>
+                                    </p:audio>
                                   </p:childTnLst>
                                 </p:cTn>
                               </p:par>
@@ -24904,6 +27811,25 @@
                                         </p:tgtEl>
                                       </p:cBhvr>
                                     </p:animEffect>
+                                    <p:audio>
+                                      <p:cMediaNode vol="80000">
+                                        <p:cTn id="1001" display="0">
+                                          <p:stCondLst>
+                                            <p:cond delay="0"/>
+                                          </p:stCondLst>
+                                          <p:endCondLst>
+                                            <p:cond evt="onStopAudio" delay="0">
+                                              <p:tgtEl>
+                                                <p:sldTgt/>
+                                              </p:tgtEl>
+                                            </p:cond>
+                                          </p:endCondLst>
+                                        </p:cTn>
+                                        <p:tgtEl>
+                                          <p:sndTgt r:embed="rIdSnd1" name="pop.wav"/>
+                                        </p:tgtEl>
+                                      </p:cMediaNode>
+                                    </p:audio>
                                   </p:childTnLst>
                                 </p:cTn>
                               </p:par>
@@ -24957,6 +27883,25 @@
                                         </p:tgtEl>
                                       </p:cBhvr>
                                     </p:animEffect>
+                                    <p:audio>
+                                      <p:cMediaNode vol="80000">
+                                        <p:cTn id="1002" display="0">
+                                          <p:stCondLst>
+                                            <p:cond delay="0"/>
+                                          </p:stCondLst>
+                                          <p:endCondLst>
+                                            <p:cond evt="onStopAudio" delay="0">
+                                              <p:tgtEl>
+                                                <p:sldTgt/>
+                                              </p:tgtEl>
+                                            </p:cond>
+                                          </p:endCondLst>
+                                        </p:cTn>
+                                        <p:tgtEl>
+                                          <p:sndTgt r:embed="rIdSnd2" name="ding.wav"/>
+                                        </p:tgtEl>
+                                      </p:cMediaNode>
+                                    </p:audio>
                                   </p:childTnLst>
                                 </p:cTn>
                               </p:par>
@@ -25010,6 +27955,25 @@
                                         </p:tgtEl>
                                       </p:cBhvr>
                                     </p:animEffect>
+                                    <p:audio>
+                                      <p:cMediaNode vol="80000">
+                                        <p:cTn id="1003" display="0">
+                                          <p:stCondLst>
+                                            <p:cond delay="0"/>
+                                          </p:stCondLst>
+                                          <p:endCondLst>
+                                            <p:cond evt="onStopAudio" delay="0">
+                                              <p:tgtEl>
+                                                <p:sldTgt/>
+                                              </p:tgtEl>
+                                            </p:cond>
+                                          </p:endCondLst>
+                                        </p:cTn>
+                                        <p:tgtEl>
+                                          <p:sndTgt r:embed="rIdSnd3" name="tick.wav"/>
+                                        </p:tgtEl>
+                                      </p:cMediaNode>
+                                    </p:audio>
                                   </p:childTnLst>
                                 </p:cTn>
                               </p:par>
@@ -25063,6 +28027,25 @@
                                         </p:tgtEl>
                                       </p:cBhvr>
                                     </p:animEffect>
+                                    <p:audio>
+                                      <p:cMediaNode vol="80000">
+                                        <p:cTn id="1004" display="0">
+                                          <p:stCondLst>
+                                            <p:cond delay="0"/>
+                                          </p:stCondLst>
+                                          <p:endCondLst>
+                                            <p:cond evt="onStopAudio" delay="0">
+                                              <p:tgtEl>
+                                                <p:sldTgt/>
+                                              </p:tgtEl>
+                                            </p:cond>
+                                          </p:endCondLst>
+                                        </p:cTn>
+                                        <p:tgtEl>
+                                          <p:sndTgt r:embed="rIdSnd1" name="pop.wav"/>
+                                        </p:tgtEl>
+                                      </p:cMediaNode>
+                                    </p:audio>
                                   </p:childTnLst>
                                 </p:cTn>
                               </p:par>
@@ -25116,6 +28099,25 @@
                                         </p:tgtEl>
                                       </p:cBhvr>
                                     </p:animEffect>
+                                    <p:audio>
+                                      <p:cMediaNode vol="80000">
+                                        <p:cTn id="1005" display="0">
+                                          <p:stCondLst>
+                                            <p:cond delay="0"/>
+                                          </p:stCondLst>
+                                          <p:endCondLst>
+                                            <p:cond evt="onStopAudio" delay="0">
+                                              <p:tgtEl>
+                                                <p:sldTgt/>
+                                              </p:tgtEl>
+                                            </p:cond>
+                                          </p:endCondLst>
+                                        </p:cTn>
+                                        <p:tgtEl>
+                                          <p:sndTgt r:embed="rIdSnd2" name="ding.wav"/>
+                                        </p:tgtEl>
+                                      </p:cMediaNode>
+                                    </p:audio>
                                   </p:childTnLst>
                                 </p:cTn>
                               </p:par>
@@ -25169,6 +28171,25 @@
                                         </p:tgtEl>
                                       </p:cBhvr>
                                     </p:animEffect>
+                                    <p:audio>
+                                      <p:cMediaNode vol="80000">
+                                        <p:cTn id="1006" display="0">
+                                          <p:stCondLst>
+                                            <p:cond delay="0"/>
+                                          </p:stCondLst>
+                                          <p:endCondLst>
+                                            <p:cond evt="onStopAudio" delay="0">
+                                              <p:tgtEl>
+                                                <p:sldTgt/>
+                                              </p:tgtEl>
+                                            </p:cond>
+                                          </p:endCondLst>
+                                        </p:cTn>
+                                        <p:tgtEl>
+                                          <p:sndTgt r:embed="rIdSnd3" name="tick.wav"/>
+                                        </p:tgtEl>
+                                      </p:cMediaNode>
+                                    </p:audio>
                                   </p:childTnLst>
                                 </p:cTn>
                               </p:par>
@@ -25222,6 +28243,25 @@
                                         </p:tgtEl>
                                       </p:cBhvr>
                                     </p:animEffect>
+                                    <p:audio>
+                                      <p:cMediaNode vol="80000">
+                                        <p:cTn id="1007" display="0">
+                                          <p:stCondLst>
+                                            <p:cond delay="0"/>
+                                          </p:stCondLst>
+                                          <p:endCondLst>
+                                            <p:cond evt="onStopAudio" delay="0">
+                                              <p:tgtEl>
+                                                <p:sldTgt/>
+                                              </p:tgtEl>
+                                            </p:cond>
+                                          </p:endCondLst>
+                                        </p:cTn>
+                                        <p:tgtEl>
+                                          <p:sndTgt r:embed="rIdSnd4" name="win.wav"/>
+                                        </p:tgtEl>
+                                      </p:cMediaNode>
+                                    </p:audio>
                                   </p:childTnLst>
                                 </p:cTn>
                               </p:par>
@@ -26046,6 +29086,25 @@
                                         </p:tgtEl>
                                       </p:cBhvr>
                                     </p:animEffect>
+                                    <p:audio>
+                                      <p:cMediaNode vol="80000">
+                                        <p:cTn id="1001" display="0">
+                                          <p:stCondLst>
+                                            <p:cond delay="0"/>
+                                          </p:stCondLst>
+                                          <p:endCondLst>
+                                            <p:cond evt="onStopAudio" delay="0">
+                                              <p:tgtEl>
+                                                <p:sldTgt/>
+                                              </p:tgtEl>
+                                            </p:cond>
+                                          </p:endCondLst>
+                                        </p:cTn>
+                                        <p:tgtEl>
+                                          <p:sndTgt r:embed="rIdSnd1" name="pop.wav"/>
+                                        </p:tgtEl>
+                                      </p:cMediaNode>
+                                    </p:audio>
                                   </p:childTnLst>
                                 </p:cTn>
                               </p:par>
@@ -26099,6 +29158,25 @@
                                         </p:tgtEl>
                                       </p:cBhvr>
                                     </p:animEffect>
+                                    <p:audio>
+                                      <p:cMediaNode vol="80000">
+                                        <p:cTn id="1002" display="0">
+                                          <p:stCondLst>
+                                            <p:cond delay="0"/>
+                                          </p:stCondLst>
+                                          <p:endCondLst>
+                                            <p:cond evt="onStopAudio" delay="0">
+                                              <p:tgtEl>
+                                                <p:sldTgt/>
+                                              </p:tgtEl>
+                                            </p:cond>
+                                          </p:endCondLst>
+                                        </p:cTn>
+                                        <p:tgtEl>
+                                          <p:sndTgt r:embed="rIdSnd2" name="ding.wav"/>
+                                        </p:tgtEl>
+                                      </p:cMediaNode>
+                                    </p:audio>
                                   </p:childTnLst>
                                 </p:cTn>
                               </p:par>
@@ -26152,6 +29230,25 @@
                                         </p:tgtEl>
                                       </p:cBhvr>
                                     </p:animEffect>
+                                    <p:audio>
+                                      <p:cMediaNode vol="80000">
+                                        <p:cTn id="1003" display="0">
+                                          <p:stCondLst>
+                                            <p:cond delay="0"/>
+                                          </p:stCondLst>
+                                          <p:endCondLst>
+                                            <p:cond evt="onStopAudio" delay="0">
+                                              <p:tgtEl>
+                                                <p:sldTgt/>
+                                              </p:tgtEl>
+                                            </p:cond>
+                                          </p:endCondLst>
+                                        </p:cTn>
+                                        <p:tgtEl>
+                                          <p:sndTgt r:embed="rIdSnd3" name="tick.wav"/>
+                                        </p:tgtEl>
+                                      </p:cMediaNode>
+                                    </p:audio>
                                   </p:childTnLst>
                                 </p:cTn>
                               </p:par>
@@ -26205,6 +29302,25 @@
                                         </p:tgtEl>
                                       </p:cBhvr>
                                     </p:animEffect>
+                                    <p:audio>
+                                      <p:cMediaNode vol="80000">
+                                        <p:cTn id="1004" display="0">
+                                          <p:stCondLst>
+                                            <p:cond delay="0"/>
+                                          </p:stCondLst>
+                                          <p:endCondLst>
+                                            <p:cond evt="onStopAudio" delay="0">
+                                              <p:tgtEl>
+                                                <p:sldTgt/>
+                                              </p:tgtEl>
+                                            </p:cond>
+                                          </p:endCondLst>
+                                        </p:cTn>
+                                        <p:tgtEl>
+                                          <p:sndTgt r:embed="rIdSnd1" name="pop.wav"/>
+                                        </p:tgtEl>
+                                      </p:cMediaNode>
+                                    </p:audio>
                                   </p:childTnLst>
                                 </p:cTn>
                               </p:par>
@@ -26258,6 +29374,25 @@
                                         </p:tgtEl>
                                       </p:cBhvr>
                                     </p:animEffect>
+                                    <p:audio>
+                                      <p:cMediaNode vol="80000">
+                                        <p:cTn id="1005" display="0">
+                                          <p:stCondLst>
+                                            <p:cond delay="0"/>
+                                          </p:stCondLst>
+                                          <p:endCondLst>
+                                            <p:cond evt="onStopAudio" delay="0">
+                                              <p:tgtEl>
+                                                <p:sldTgt/>
+                                              </p:tgtEl>
+                                            </p:cond>
+                                          </p:endCondLst>
+                                        </p:cTn>
+                                        <p:tgtEl>
+                                          <p:sndTgt r:embed="rIdSnd2" name="ding.wav"/>
+                                        </p:tgtEl>
+                                      </p:cMediaNode>
+                                    </p:audio>
                                   </p:childTnLst>
                                 </p:cTn>
                               </p:par>
@@ -26311,6 +29446,25 @@
                                         </p:tgtEl>
                                       </p:cBhvr>
                                     </p:animEffect>
+                                    <p:audio>
+                                      <p:cMediaNode vol="80000">
+                                        <p:cTn id="1006" display="0">
+                                          <p:stCondLst>
+                                            <p:cond delay="0"/>
+                                          </p:stCondLst>
+                                          <p:endCondLst>
+                                            <p:cond evt="onStopAudio" delay="0">
+                                              <p:tgtEl>
+                                                <p:sldTgt/>
+                                              </p:tgtEl>
+                                            </p:cond>
+                                          </p:endCondLst>
+                                        </p:cTn>
+                                        <p:tgtEl>
+                                          <p:sndTgt r:embed="rIdSnd3" name="tick.wav"/>
+                                        </p:tgtEl>
+                                      </p:cMediaNode>
+                                    </p:audio>
                                   </p:childTnLst>
                                 </p:cTn>
                               </p:par>
@@ -26364,6 +29518,25 @@
                                         </p:tgtEl>
                                       </p:cBhvr>
                                     </p:animEffect>
+                                    <p:audio>
+                                      <p:cMediaNode vol="80000">
+                                        <p:cTn id="1007" display="0">
+                                          <p:stCondLst>
+                                            <p:cond delay="0"/>
+                                          </p:stCondLst>
+                                          <p:endCondLst>
+                                            <p:cond evt="onStopAudio" delay="0">
+                                              <p:tgtEl>
+                                                <p:sldTgt/>
+                                              </p:tgtEl>
+                                            </p:cond>
+                                          </p:endCondLst>
+                                        </p:cTn>
+                                        <p:tgtEl>
+                                          <p:sndTgt r:embed="rIdSnd1" name="pop.wav"/>
+                                        </p:tgtEl>
+                                      </p:cMediaNode>
+                                    </p:audio>
                                   </p:childTnLst>
                                 </p:cTn>
                               </p:par>
@@ -26417,6 +29590,25 @@
                                         </p:tgtEl>
                                       </p:cBhvr>
                                     </p:animEffect>
+                                    <p:audio>
+                                      <p:cMediaNode vol="80000">
+                                        <p:cTn id="1008" display="0">
+                                          <p:stCondLst>
+                                            <p:cond delay="0"/>
+                                          </p:stCondLst>
+                                          <p:endCondLst>
+                                            <p:cond evt="onStopAudio" delay="0">
+                                              <p:tgtEl>
+                                                <p:sldTgt/>
+                                              </p:tgtEl>
+                                            </p:cond>
+                                          </p:endCondLst>
+                                        </p:cTn>
+                                        <p:tgtEl>
+                                          <p:sndTgt r:embed="rIdSnd2" name="ding.wav"/>
+                                        </p:tgtEl>
+                                      </p:cMediaNode>
+                                    </p:audio>
                                   </p:childTnLst>
                                 </p:cTn>
                               </p:par>
@@ -26470,6 +29662,25 @@
                                         </p:tgtEl>
                                       </p:cBhvr>
                                     </p:animEffect>
+                                    <p:audio>
+                                      <p:cMediaNode vol="80000">
+                                        <p:cTn id="1009" display="0">
+                                          <p:stCondLst>
+                                            <p:cond delay="0"/>
+                                          </p:stCondLst>
+                                          <p:endCondLst>
+                                            <p:cond evt="onStopAudio" delay="0">
+                                              <p:tgtEl>
+                                                <p:sldTgt/>
+                                              </p:tgtEl>
+                                            </p:cond>
+                                          </p:endCondLst>
+                                        </p:cTn>
+                                        <p:tgtEl>
+                                          <p:sndTgt r:embed="rIdSnd3" name="tick.wav"/>
+                                        </p:tgtEl>
+                                      </p:cMediaNode>
+                                    </p:audio>
                                   </p:childTnLst>
                                 </p:cTn>
                               </p:par>
@@ -26523,6 +29734,25 @@
                                         </p:tgtEl>
                                       </p:cBhvr>
                                     </p:animEffect>
+                                    <p:audio>
+                                      <p:cMediaNode vol="80000">
+                                        <p:cTn id="1010" display="0">
+                                          <p:stCondLst>
+                                            <p:cond delay="0"/>
+                                          </p:stCondLst>
+                                          <p:endCondLst>
+                                            <p:cond evt="onStopAudio" delay="0">
+                                              <p:tgtEl>
+                                                <p:sldTgt/>
+                                              </p:tgtEl>
+                                            </p:cond>
+                                          </p:endCondLst>
+                                        </p:cTn>
+                                        <p:tgtEl>
+                                          <p:sndTgt r:embed="rIdSnd4" name="win.wav"/>
+                                        </p:tgtEl>
+                                      </p:cMediaNode>
+                                    </p:audio>
                                   </p:childTnLst>
                                 </p:cTn>
                               </p:par>

</xml_diff>